<commit_message>
feat(v0.9.5): replace 8-layout PowerPoint template and add per-story NEWS_TITLE dividers
</commit_message>
<xml_diff>
--- a/assets/templates/weekly-it-news-design-template.pptx
+++ b/assets/templates/weekly-it-news-design-template.pptx
@@ -5,16 +5,17 @@
     <p:sldMasterId id="2147483648" r:id="rId4"/>
   </p:sldMasterIdLst>
   <p:notesMasterIdLst>
-    <p:notesMasterId r:id="rId36"/>
+    <p:notesMasterId r:id="rId13"/>
   </p:notesMasterIdLst>
   <p:sldIdLst>
     <p:sldId id="463" r:id="rId5"/>
-    <p:sldId id="464" r:id="rId13"/>
-    <p:sldId id="465" r:id="rId14"/>
-    <p:sldId id="466" r:id="rId15"/>
-    <p:sldId id="467" r:id="rId16"/>
-    <p:sldId id="468" r:id="rId17"/>
-    <p:sldId id="469" r:id="rId18"/>
+    <p:sldId id="464" r:id="rId6"/>
+    <p:sldId id="470" r:id="rId7"/>
+    <p:sldId id="465" r:id="rId8"/>
+    <p:sldId id="466" r:id="rId9"/>
+    <p:sldId id="467" r:id="rId10"/>
+    <p:sldId id="468" r:id="rId11"/>
+    <p:sldId id="469" r:id="rId12"/>
   </p:sldIdLst>
   <p:sldSz cx="12192000" cy="6858000"/>
   <p:notesSz cx="6858000" cy="9144000"/>
@@ -1493,7 +1494,7 @@
           <a:p>
             <a:fld id="{0F373FFE-1AAE-4D98-B7DA-A443435ADEB6}" type="datetimeFigureOut">
               <a:rPr kumimoji="1" lang="ja-JP" altLang="en-US" smtClean="0"/>
-              <a:t>2026/3/15</a:t>
+              <a:t>2026/10/26</a:t>
             </a:fld>
             <a:endParaRPr kumimoji="1" lang="ja-JP" altLang="en-US"/>
           </a:p>
@@ -2001,7 +2002,7 @@
           <a:p>
             <a:fld id="{8B9A548D-B44B-407D-B4A1-42D180C60399}" type="datetimeFigureOut">
               <a:rPr kumimoji="1" lang="ja-JP" altLang="en-US" smtClean="0"/>
-              <a:t>2026/3/15</a:t>
+              <a:t>2026/10/26</a:t>
             </a:fld>
             <a:endParaRPr kumimoji="1" lang="ja-JP" altLang="en-US"/>
           </a:p>
@@ -2201,7 +2202,7 @@
           <a:p>
             <a:fld id="{8B9A548D-B44B-407D-B4A1-42D180C60399}" type="datetimeFigureOut">
               <a:rPr kumimoji="1" lang="ja-JP" altLang="en-US" smtClean="0"/>
-              <a:t>2026/3/15</a:t>
+              <a:t>2026/10/26</a:t>
             </a:fld>
             <a:endParaRPr kumimoji="1" lang="ja-JP" altLang="en-US"/>
           </a:p>
@@ -2411,7 +2412,7 @@
           <a:p>
             <a:fld id="{8B9A548D-B44B-407D-B4A1-42D180C60399}" type="datetimeFigureOut">
               <a:rPr kumimoji="1" lang="ja-JP" altLang="en-US" smtClean="0"/>
-              <a:t>2026/3/15</a:t>
+              <a:t>2026/10/26</a:t>
             </a:fld>
             <a:endParaRPr kumimoji="1" lang="ja-JP" altLang="en-US"/>
           </a:p>
@@ -2611,7 +2612,7 @@
           <a:p>
             <a:fld id="{8B9A548D-B44B-407D-B4A1-42D180C60399}" type="datetimeFigureOut">
               <a:rPr kumimoji="1" lang="ja-JP" altLang="en-US" smtClean="0"/>
-              <a:t>2026/3/15</a:t>
+              <a:t>2026/10/26</a:t>
             </a:fld>
             <a:endParaRPr kumimoji="1" lang="ja-JP" altLang="en-US"/>
           </a:p>
@@ -2887,7 +2888,7 @@
           <a:p>
             <a:fld id="{8B9A548D-B44B-407D-B4A1-42D180C60399}" type="datetimeFigureOut">
               <a:rPr kumimoji="1" lang="ja-JP" altLang="en-US" smtClean="0"/>
-              <a:t>2026/3/15</a:t>
+              <a:t>2026/10/26</a:t>
             </a:fld>
             <a:endParaRPr kumimoji="1" lang="ja-JP" altLang="en-US"/>
           </a:p>
@@ -3155,7 +3156,7 @@
           <a:p>
             <a:fld id="{8B9A548D-B44B-407D-B4A1-42D180C60399}" type="datetimeFigureOut">
               <a:rPr kumimoji="1" lang="ja-JP" altLang="en-US" smtClean="0"/>
-              <a:t>2026/3/15</a:t>
+              <a:t>2026/10/26</a:t>
             </a:fld>
             <a:endParaRPr kumimoji="1" lang="ja-JP" altLang="en-US"/>
           </a:p>
@@ -3570,7 +3571,7 @@
           <a:p>
             <a:fld id="{8B9A548D-B44B-407D-B4A1-42D180C60399}" type="datetimeFigureOut">
               <a:rPr kumimoji="1" lang="ja-JP" altLang="en-US" smtClean="0"/>
-              <a:t>2026/3/15</a:t>
+              <a:t>2026/10/26</a:t>
             </a:fld>
             <a:endParaRPr kumimoji="1" lang="ja-JP" altLang="en-US"/>
           </a:p>
@@ -3712,7 +3713,7 @@
           <a:p>
             <a:fld id="{8B9A548D-B44B-407D-B4A1-42D180C60399}" type="datetimeFigureOut">
               <a:rPr kumimoji="1" lang="ja-JP" altLang="en-US" smtClean="0"/>
-              <a:t>2026/3/15</a:t>
+              <a:t>2026/10/26</a:t>
             </a:fld>
             <a:endParaRPr kumimoji="1" lang="ja-JP" altLang="en-US"/>
           </a:p>
@@ -3825,7 +3826,7 @@
           <a:p>
             <a:fld id="{8B9A548D-B44B-407D-B4A1-42D180C60399}" type="datetimeFigureOut">
               <a:rPr kumimoji="1" lang="ja-JP" altLang="en-US" smtClean="0"/>
-              <a:t>2026/3/15</a:t>
+              <a:t>2026/10/26</a:t>
             </a:fld>
             <a:endParaRPr kumimoji="1" lang="ja-JP" altLang="en-US"/>
           </a:p>
@@ -4138,7 +4139,7 @@
           <a:p>
             <a:fld id="{8B9A548D-B44B-407D-B4A1-42D180C60399}" type="datetimeFigureOut">
               <a:rPr kumimoji="1" lang="ja-JP" altLang="en-US" smtClean="0"/>
-              <a:t>2026/3/15</a:t>
+              <a:t>2026/10/26</a:t>
             </a:fld>
             <a:endParaRPr kumimoji="1" lang="ja-JP" altLang="en-US"/>
           </a:p>
@@ -4427,7 +4428,7 @@
           <a:p>
             <a:fld id="{8B9A548D-B44B-407D-B4A1-42D180C60399}" type="datetimeFigureOut">
               <a:rPr kumimoji="1" lang="ja-JP" altLang="en-US" smtClean="0"/>
-              <a:t>2026/3/15</a:t>
+              <a:t>2026/10/26</a:t>
             </a:fld>
             <a:endParaRPr kumimoji="1" lang="ja-JP" altLang="en-US"/>
           </a:p>
@@ -4670,7 +4671,7 @@
           <a:p>
             <a:fld id="{8B9A548D-B44B-407D-B4A1-42D180C60399}" type="datetimeFigureOut">
               <a:rPr kumimoji="1" lang="ja-JP" altLang="en-US" smtClean="0"/>
-              <a:t>2026/3/15</a:t>
+              <a:t>2026/10/26</a:t>
             </a:fld>
             <a:endParaRPr kumimoji="1" lang="ja-JP" altLang="en-US"/>
           </a:p>
@@ -5278,7 +5279,7 @@
         <p:spPr>
           <a:xfrm>
             <a:off x="0" y="99660"/>
-            <a:ext cx="10660482" cy="1569660"/>
+            <a:ext cx="10660482" cy="1942815"/>
           </a:xfrm>
           <a:prstGeom prst="rect">
             <a:avLst/>
@@ -5287,12 +5288,12 @@
         </p:spPr>
         <p:txBody>
           <a:bodyPr wrap="none" rtlCol="0">
-            <a:spAutoFit/>
+            <a:normAutofit/>
           </a:bodyPr>
           <a:lstStyle/>
           <a:p>
             <a:r>
-              <a:rPr lang="en-US" altLang="ja-JP" sz="9600" b="1" dirty="0">
+              <a:rPr lang="en-US" altLang="ja-JP" sz="9600" b="1">
                 <a:solidFill>
                   <a:srgbClr val="FF0000"/>
                 </a:solidFill>
@@ -5388,7 +5389,7 @@
         <p:spPr>
           <a:xfrm>
             <a:off x="4334256" y="1901952"/>
-            <a:ext cx="6766560" cy="694944"/>
+            <a:ext cx="3158237" cy="600164"/>
           </a:xfrm>
           <a:prstGeom prst="rect">
             <a:avLst/>
@@ -5402,7 +5403,7 @@
           <a:lstStyle/>
           <a:p>
             <a:r>
-              <a:rPr sz="3300" b="1">
+              <a:rPr lang="ja-JP" altLang="en-US" sz="3300" b="1">
                 <a:solidFill>
                   <a:srgbClr val="BE0000"/>
                 </a:solidFill>
@@ -5461,7 +5462,7 @@
 </file>
 
 <file path=ppt/slides/slide2.xml><?xml version="1.0" encoding="utf-8"?>
-<p:sld xmlns:a="http://schemas.openxmlformats.org/drawingml/2006/main" xmlns:p="http://schemas.openxmlformats.org/presentationml/2006/main" xmlns:r="http://schemas.openxmlformats.org/officeDocument/2006/relationships">
+<p:sld xmlns:a="http://schemas.openxmlformats.org/drawingml/2006/main" xmlns:r="http://schemas.openxmlformats.org/officeDocument/2006/relationships" xmlns:p="http://schemas.openxmlformats.org/presentationml/2006/main">
   <p:cSld>
     <p:bg>
       <p:bgPr>
@@ -5477,7 +5478,14 @@
         <p:cNvGrpSpPr/>
         <p:nvPr/>
       </p:nvGrpSpPr>
-      <p:grpSpPr/>
+      <p:grpSpPr>
+        <a:xfrm>
+          <a:off x="0" y="0"/>
+          <a:ext cx="0" cy="0"/>
+          <a:chOff x="0" y="0"/>
+          <a:chExt cx="0" cy="0"/>
+        </a:xfrm>
+      </p:grpSpPr>
       <p:sp>
         <p:nvSpPr>
           <p:cNvPr id="2" name="TextBox 1"/>
@@ -5487,7 +5495,7 @@
         <p:spPr>
           <a:xfrm>
             <a:off x="566928" y="329184"/>
-            <a:ext cx="10927080" cy="594360"/>
+            <a:ext cx="10927080" cy="461665"/>
           </a:xfrm>
           <a:prstGeom prst="rect">
             <a:avLst/>
@@ -5495,7 +5503,7 @@
           <a:noFill/>
         </p:spPr>
         <p:txBody>
-          <a:bodyPr wrap="square" lIns="0" rIns="0" tIns="0" bIns="0">
+          <a:bodyPr wrap="square" lIns="0" tIns="0" rIns="0" bIns="0">
             <a:spAutoFit/>
           </a:bodyPr>
           <a:lstStyle/>
@@ -5506,7 +5514,7 @@
               </a:spcAft>
               <a:defRPr sz="3000" b="1">
                 <a:solidFill>
-                  <a:srgbClr val="C00000"/>
+                  <a:srgbClr val="0050E6"/>
                 </a:solidFill>
                 <a:latin typeface="Yu Gothic"/>
               </a:defRPr>
@@ -5514,6 +5522,7 @@
             <a:r>
               <a:t>今週のトピック</a:t>
             </a:r>
+            <a:endParaRPr lang="ja-JP" altLang="en-US"/>
           </a:p>
         </p:txBody>
       </p:sp>
@@ -5532,7 +5541,7 @@
             <a:avLst/>
           </a:prstGeom>
           <a:solidFill>
-            <a:srgbClr val="C00000"/>
+            <a:srgbClr val="FFB800"/>
           </a:solidFill>
           <a:ln>
             <a:noFill/>
@@ -5557,19 +5566,20 @@
           <a:lstStyle/>
           <a:p>
             <a:pPr algn="ctr"/>
-          </a:p>
-        </p:txBody>
-      </p:sp>
-      <p:sp>
-        <p:nvSpPr>
-          <p:cNvPr id="4" name="TextBox 3"/>
+            <a:endParaRPr/>
+          </a:p>
+        </p:txBody>
+      </p:sp>
+      <p:sp>
+        <p:nvSpPr>
+          <p:cNvPr id="5" name="TextBox 4"/>
           <p:cNvSpPr txBox="1"/>
           <p:nvPr/>
         </p:nvSpPr>
         <p:spPr>
           <a:xfrm>
-            <a:off x="566928" y="6492240"/>
-            <a:ext cx="10789920" cy="201168"/>
+            <a:off x="804672" y="1508760"/>
+            <a:ext cx="10515600" cy="1426031"/>
           </a:xfrm>
           <a:prstGeom prst="rect">
             <a:avLst/>
@@ -5577,46 +5587,7 @@
           <a:noFill/>
         </p:spPr>
         <p:txBody>
-          <a:bodyPr wrap="square" lIns="0" rIns="0" tIns="0" bIns="0">
-            <a:spAutoFit/>
-          </a:bodyPr>
-          <a:lstStyle/>
-          <a:p>
-            <a:pPr>
-              <a:spcAft>
-                <a:spcPts val="700"/>
-              </a:spcAft>
-              <a:defRPr sz="900" b="0">
-                <a:solidFill>
-                  <a:srgbClr val="696969"/>
-                </a:solidFill>
-                <a:latin typeface="Yu Gothic"/>
-              </a:defRPr>
-            </a:pPr>
-            <a:r>
-              <a:t>Weekly IT News！  •  レイアウト見本（実際の内容に差し替え）</a:t>
-            </a:r>
-          </a:p>
-        </p:txBody>
-      </p:sp>
-      <p:sp>
-        <p:nvSpPr>
-          <p:cNvPr id="5" name="TextBox 4"/>
-          <p:cNvSpPr txBox="1"/>
-          <p:nvPr/>
-        </p:nvSpPr>
-        <p:spPr>
-          <a:xfrm>
-            <a:off x="804672" y="1508760"/>
-            <a:ext cx="10515600" cy="4297680"/>
-          </a:xfrm>
-          <a:prstGeom prst="rect">
-            <a:avLst/>
-          </a:prstGeom>
-          <a:noFill/>
-        </p:spPr>
-        <p:txBody>
-          <a:bodyPr wrap="square" lIns="0" rIns="0" tIns="0" bIns="0">
+          <a:bodyPr wrap="square" lIns="0" tIns="0" rIns="0" bIns="0">
             <a:spAutoFit/>
           </a:bodyPr>
           <a:lstStyle/>
@@ -5627,7 +5598,7 @@
               </a:spcAft>
               <a:defRPr sz="2700" b="0">
                 <a:solidFill>
-                  <a:srgbClr val="1C1C1C"/>
+                  <a:srgbClr val="0A1A3A"/>
                 </a:solidFill>
                 <a:latin typeface="Yu Gothic"/>
               </a:defRPr>
@@ -5635,6 +5606,7 @@
             <a:r>
               <a:t>・ニュースA：今週のトピックを簡潔に書く</a:t>
             </a:r>
+            <a:endParaRPr lang="ja-JP" altLang="en-US"/>
           </a:p>
           <a:p>
             <a:pPr>
@@ -5643,7 +5615,7 @@
               </a:spcAft>
               <a:defRPr sz="2700" b="0">
                 <a:solidFill>
-                  <a:srgbClr val="1C1C1C"/>
+                  <a:srgbClr val="0A1A3A"/>
                 </a:solidFill>
                 <a:latin typeface="Yu Gothic"/>
               </a:defRPr>
@@ -5651,6 +5623,7 @@
             <a:r>
               <a:t>・ニュースB：長いタイトルは必要に応じ改行</a:t>
             </a:r>
+            <a:endParaRPr lang="ja-JP" altLang="en-US"/>
           </a:p>
           <a:p>
             <a:pPr>
@@ -5659,7 +5632,7 @@
               </a:spcAft>
               <a:defRPr sz="2700" b="0">
                 <a:solidFill>
-                  <a:srgbClr val="1C1C1C"/>
+                  <a:srgbClr val="0A1A3A"/>
                 </a:solidFill>
                 <a:latin typeface="Yu Gothic"/>
               </a:defRPr>
@@ -5667,6 +5640,7 @@
             <a:r>
               <a:t>・ニュースC：ニュースは週により増減</a:t>
             </a:r>
+            <a:endParaRPr lang="ja-JP" altLang="en-US"/>
           </a:p>
         </p:txBody>
       </p:sp>
@@ -5679,7 +5653,7 @@
 </file>
 
 <file path=ppt/slides/slide3.xml><?xml version="1.0" encoding="utf-8"?>
-<p:sld xmlns:a="http://schemas.openxmlformats.org/drawingml/2006/main" xmlns:p="http://schemas.openxmlformats.org/presentationml/2006/main" xmlns:r="http://schemas.openxmlformats.org/officeDocument/2006/relationships">
+<p:sld xmlns:a="http://schemas.openxmlformats.org/drawingml/2006/main" xmlns:r="http://schemas.openxmlformats.org/officeDocument/2006/relationships" xmlns:p="http://schemas.openxmlformats.org/presentationml/2006/main">
   <p:cSld>
     <p:bg>
       <p:bgPr>
@@ -5695,17 +5669,24 @@
         <p:cNvGrpSpPr/>
         <p:nvPr/>
       </p:nvGrpSpPr>
-      <p:grpSpPr/>
-      <p:sp>
-        <p:nvSpPr>
-          <p:cNvPr id="2" name="TextBox 1"/>
+      <p:grpSpPr>
+        <a:xfrm>
+          <a:off x="0" y="0"/>
+          <a:ext cx="0" cy="0"/>
+          <a:chOff x="0" y="0"/>
+          <a:chExt cx="0" cy="0"/>
+        </a:xfrm>
+      </p:grpSpPr>
+      <p:sp>
+        <p:nvSpPr>
+          <p:cNvPr id="5" name="Big Number"/>
           <p:cNvSpPr txBox="1"/>
           <p:nvPr/>
         </p:nvSpPr>
         <p:spPr>
           <a:xfrm>
-            <a:off x="566928" y="329184"/>
-            <a:ext cx="10927080" cy="594360"/>
+            <a:off x="7315200" y="3474720"/>
+            <a:ext cx="4572000" cy="3017520"/>
           </a:xfrm>
           <a:prstGeom prst="rect">
             <a:avLst/>
@@ -5713,7 +5694,205 @@
           <a:noFill/>
         </p:spPr>
         <p:txBody>
-          <a:bodyPr wrap="square" lIns="0" rIns="0" tIns="0" bIns="0">
+          <a:bodyPr wrap="none" lIns="0" tIns="0" rIns="0" bIns="0" anchor="b">
+            <a:noAutofit/>
+          </a:bodyPr>
+          <a:lstStyle/>
+          <a:p>
+            <a:pPr algn="r"/>
+            <a:r>
+              <a:rPr lang="en-US" altLang="ja-JP" sz="20000" b="1">
+                <a:solidFill>
+                  <a:srgbClr val="EAF2FF"/>
+                </a:solidFill>
+                <a:latin typeface="Arial"/>
+              </a:rPr>
+              <a:t>01</a:t>
+            </a:r>
+          </a:p>
+        </p:txBody>
+      </p:sp>
+      <p:sp>
+        <p:nvSpPr>
+          <p:cNvPr id="6" name="Vertical Bar"/>
+          <p:cNvSpPr/>
+          <p:nvPr/>
+        </p:nvSpPr>
+        <p:spPr>
+          <a:xfrm>
+            <a:off x="566928" y="2286000"/>
+            <a:ext cx="91440" cy="2286000"/>
+          </a:xfrm>
+          <a:prstGeom prst="rect">
+            <a:avLst/>
+          </a:prstGeom>
+          <a:solidFill>
+            <a:srgbClr val="0050E6"/>
+          </a:solidFill>
+          <a:ln>
+            <a:noFill/>
+          </a:ln>
+        </p:spPr>
+        <p:txBody>
+          <a:bodyPr/>
+          <a:lstStyle/>
+          <a:p>
+            <a:endParaRPr lang="ja-JP" altLang="en-US"/>
+          </a:p>
+        </p:txBody>
+      </p:sp>
+      <p:sp>
+        <p:nvSpPr>
+          <p:cNvPr id="2" name="News Label"/>
+          <p:cNvSpPr txBox="1"/>
+          <p:nvPr/>
+        </p:nvSpPr>
+        <p:spPr>
+          <a:xfrm>
+            <a:off x="914400" y="2286000"/>
+            <a:ext cx="6400800" cy="365760"/>
+          </a:xfrm>
+          <a:prstGeom prst="rect">
+            <a:avLst/>
+          </a:prstGeom>
+          <a:noFill/>
+        </p:spPr>
+        <p:txBody>
+          <a:bodyPr wrap="square" lIns="0" tIns="0" rIns="0" bIns="0" anchor="t">
+            <a:noAutofit/>
+          </a:bodyPr>
+          <a:lstStyle/>
+          <a:p>
+            <a:r>
+              <a:rPr lang="en-US" altLang="ja-JP" sz="1800" b="1" spc="600">
+                <a:solidFill>
+                  <a:srgbClr val="0050E6"/>
+                </a:solidFill>
+                <a:latin typeface="Arial"/>
+              </a:rPr>
+              <a:t>NEWS 01</a:t>
+            </a:r>
+          </a:p>
+        </p:txBody>
+      </p:sp>
+      <p:sp>
+        <p:nvSpPr>
+          <p:cNvPr id="4" name="News Title"/>
+          <p:cNvSpPr txBox="1"/>
+          <p:nvPr/>
+        </p:nvSpPr>
+        <p:spPr>
+          <a:xfrm>
+            <a:off x="914400" y="2834640"/>
+            <a:ext cx="10363200" cy="1371600"/>
+          </a:xfrm>
+          <a:prstGeom prst="rect">
+            <a:avLst/>
+          </a:prstGeom>
+          <a:noFill/>
+        </p:spPr>
+        <p:txBody>
+          <a:bodyPr wrap="square" lIns="0" tIns="0" rIns="0" bIns="0" anchor="t">
+            <a:normAutofit/>
+          </a:bodyPr>
+          <a:lstStyle/>
+          <a:p>
+            <a:pPr>
+              <a:lnSpc>
+                <a:spcPct val="110000"/>
+              </a:lnSpc>
+            </a:pPr>
+            <a:r>
+              <a:rPr lang="ja-JP" altLang="en-US" sz="4800" b="1">
+                <a:solidFill>
+                  <a:srgbClr val="0A1A3A"/>
+                </a:solidFill>
+              </a:rPr>
+              <a:t>ニュースのタイトル</a:t>
+            </a:r>
+          </a:p>
+        </p:txBody>
+      </p:sp>
+      <p:sp>
+        <p:nvSpPr>
+          <p:cNvPr id="3" name="Accent Bar"/>
+          <p:cNvSpPr/>
+          <p:nvPr/>
+        </p:nvSpPr>
+        <p:spPr>
+          <a:xfrm>
+            <a:off x="914400" y="4480560"/>
+            <a:ext cx="914400" cy="45720"/>
+          </a:xfrm>
+          <a:prstGeom prst="rect">
+            <a:avLst/>
+          </a:prstGeom>
+          <a:solidFill>
+            <a:srgbClr val="FFB800"/>
+          </a:solidFill>
+          <a:ln>
+            <a:noFill/>
+          </a:ln>
+        </p:spPr>
+        <p:txBody>
+          <a:bodyPr/>
+          <a:lstStyle/>
+          <a:p>
+            <a:endParaRPr lang="ja-JP" altLang="en-US"/>
+          </a:p>
+        </p:txBody>
+      </p:sp>
+    </p:spTree>
+  </p:cSld>
+  <p:clrMapOvr>
+    <a:masterClrMapping/>
+  </p:clrMapOvr>
+</p:sld>
+</file>
+
+<file path=ppt/slides/slide4.xml><?xml version="1.0" encoding="utf-8"?>
+<p:sld xmlns:a="http://schemas.openxmlformats.org/drawingml/2006/main" xmlns:r="http://schemas.openxmlformats.org/officeDocument/2006/relationships" xmlns:p="http://schemas.openxmlformats.org/presentationml/2006/main">
+  <p:cSld>
+    <p:bg>
+      <p:bgPr>
+        <a:solidFill>
+          <a:srgbClr val="FFFFFF"/>
+        </a:solidFill>
+        <a:effectLst/>
+      </p:bgPr>
+    </p:bg>
+    <p:spTree>
+      <p:nvGrpSpPr>
+        <p:cNvPr id="1" name=""/>
+        <p:cNvGrpSpPr/>
+        <p:nvPr/>
+      </p:nvGrpSpPr>
+      <p:grpSpPr>
+        <a:xfrm>
+          <a:off x="0" y="0"/>
+          <a:ext cx="0" cy="0"/>
+          <a:chOff x="0" y="0"/>
+          <a:chExt cx="0" cy="0"/>
+        </a:xfrm>
+      </p:grpSpPr>
+      <p:sp>
+        <p:nvSpPr>
+          <p:cNvPr id="2" name="TextBox 1"/>
+          <p:cNvSpPr txBox="1"/>
+          <p:nvPr/>
+        </p:nvSpPr>
+        <p:spPr>
+          <a:xfrm>
+            <a:off x="566928" y="329184"/>
+            <a:ext cx="10927080" cy="461665"/>
+          </a:xfrm>
+          <a:prstGeom prst="rect">
+            <a:avLst/>
+          </a:prstGeom>
+          <a:noFill/>
+        </p:spPr>
+        <p:txBody>
+          <a:bodyPr wrap="square" lIns="0" tIns="0" rIns="0" bIns="0">
             <a:spAutoFit/>
           </a:bodyPr>
           <a:lstStyle/>
@@ -5724,7 +5903,7 @@
               </a:spcAft>
               <a:defRPr sz="3000" b="1">
                 <a:solidFill>
-                  <a:srgbClr val="C00000"/>
+                  <a:srgbClr val="0050E6"/>
                 </a:solidFill>
                 <a:latin typeface="Yu Gothic"/>
               </a:defRPr>
@@ -5732,6 +5911,7 @@
             <a:r>
               <a:t>ニュースの紹介タイトル</a:t>
             </a:r>
+            <a:endParaRPr lang="ja-JP" altLang="en-US"/>
           </a:p>
         </p:txBody>
       </p:sp>
@@ -5750,7 +5930,7 @@
             <a:avLst/>
           </a:prstGeom>
           <a:solidFill>
-            <a:srgbClr val="C00000"/>
+            <a:srgbClr val="FFB800"/>
           </a:solidFill>
           <a:ln>
             <a:noFill/>
@@ -5775,19 +5955,20 @@
           <a:lstStyle/>
           <a:p>
             <a:pPr algn="ctr"/>
-          </a:p>
-        </p:txBody>
-      </p:sp>
-      <p:sp>
-        <p:nvSpPr>
-          <p:cNvPr id="4" name="TextBox 3"/>
+            <a:endParaRPr/>
+          </a:p>
+        </p:txBody>
+      </p:sp>
+      <p:sp>
+        <p:nvSpPr>
+          <p:cNvPr id="5" name="TextBox 4"/>
           <p:cNvSpPr txBox="1"/>
           <p:nvPr/>
         </p:nvSpPr>
         <p:spPr>
           <a:xfrm>
-            <a:off x="566928" y="6492240"/>
-            <a:ext cx="10789920" cy="201168"/>
+            <a:off x="566928" y="1417320"/>
+            <a:ext cx="10607040" cy="384721"/>
           </a:xfrm>
           <a:prstGeom prst="rect">
             <a:avLst/>
@@ -5795,7 +5976,7 @@
           <a:noFill/>
         </p:spPr>
         <p:txBody>
-          <a:bodyPr wrap="square" lIns="0" rIns="0" tIns="0" bIns="0">
+          <a:bodyPr wrap="square" lIns="0" tIns="0" rIns="0" bIns="0">
             <a:spAutoFit/>
           </a:bodyPr>
           <a:lstStyle/>
@@ -5804,29 +5985,30 @@
               <a:spcAft>
                 <a:spcPts val="700"/>
               </a:spcAft>
-              <a:defRPr sz="900" b="0">
+              <a:defRPr sz="2500" b="1">
                 <a:solidFill>
-                  <a:srgbClr val="696969"/>
+                  <a:srgbClr val="0A1A3A"/>
                 </a:solidFill>
                 <a:latin typeface="Yu Gothic"/>
               </a:defRPr>
             </a:pPr>
             <a:r>
-              <a:t>Weekly IT News！  •  レイアウト見本（実際の内容に差し替え）</a:t>
-            </a:r>
-          </a:p>
-        </p:txBody>
-      </p:sp>
-      <p:sp>
-        <p:nvSpPr>
-          <p:cNvPr id="5" name="TextBox 4"/>
+              <a:t>何が起きたかを最初に説明する</a:t>
+            </a:r>
+            <a:endParaRPr lang="ja-JP" altLang="en-US"/>
+          </a:p>
+        </p:txBody>
+      </p:sp>
+      <p:sp>
+        <p:nvSpPr>
+          <p:cNvPr id="6" name="TextBox 5"/>
           <p:cNvSpPr txBox="1"/>
           <p:nvPr/>
         </p:nvSpPr>
         <p:spPr>
           <a:xfrm>
-            <a:off x="768096" y="1417320"/>
-            <a:ext cx="10607040" cy="502920"/>
+            <a:off x="566928" y="2212848"/>
+            <a:ext cx="10515600" cy="1241365"/>
           </a:xfrm>
           <a:prstGeom prst="rect">
             <a:avLst/>
@@ -5834,7 +6016,7 @@
           <a:noFill/>
         </p:spPr>
         <p:txBody>
-          <a:bodyPr wrap="square" lIns="0" rIns="0" tIns="0" bIns="0">
+          <a:bodyPr wrap="square" lIns="0" tIns="0" rIns="0" bIns="0">
             <a:spAutoFit/>
           </a:bodyPr>
           <a:lstStyle/>
@@ -5843,29 +6025,64 @@
               <a:spcAft>
                 <a:spcPts val="700"/>
               </a:spcAft>
-              <a:defRPr sz="2500" b="1">
+              <a:defRPr sz="2300" b="0">
                 <a:solidFill>
-                  <a:srgbClr val="1C1C1C"/>
+                  <a:srgbClr val="0A1A3A"/>
                 </a:solidFill>
                 <a:latin typeface="Yu Gothic"/>
               </a:defRPr>
             </a:pPr>
             <a:r>
-              <a:t>何が起きたかを最初に説明する</a:t>
-            </a:r>
-          </a:p>
-        </p:txBody>
-      </p:sp>
-      <p:sp>
-        <p:nvSpPr>
-          <p:cNvPr id="6" name="TextBox 5"/>
+              <a:t>・結論：ここに事実として確認できた内容</a:t>
+            </a:r>
+            <a:endParaRPr lang="ja-JP" altLang="en-US"/>
+          </a:p>
+          <a:p>
+            <a:pPr>
+              <a:spcAft>
+                <a:spcPts val="700"/>
+              </a:spcAft>
+              <a:defRPr sz="2300" b="0">
+                <a:solidFill>
+                  <a:srgbClr val="0A1A3A"/>
+                </a:solidFill>
+                <a:latin typeface="Yu Gothic"/>
+              </a:defRPr>
+            </a:pPr>
+            <a:r>
+              <a:t>・技術的背景：どうして重要なのか</a:t>
+            </a:r>
+            <a:endParaRPr lang="ja-JP" altLang="en-US"/>
+          </a:p>
+          <a:p>
+            <a:pPr>
+              <a:spcAft>
+                <a:spcPts val="700"/>
+              </a:spcAft>
+              <a:defRPr sz="2300" b="0">
+                <a:solidFill>
+                  <a:srgbClr val="0A1A3A"/>
+                </a:solidFill>
+                <a:latin typeface="Yu Gothic"/>
+              </a:defRPr>
+            </a:pPr>
+            <a:r>
+              <a:t>・発表者の評価：事実とは明確に分ける</a:t>
+            </a:r>
+            <a:endParaRPr lang="ja-JP" altLang="en-US"/>
+          </a:p>
+        </p:txBody>
+      </p:sp>
+      <p:sp>
+        <p:nvSpPr>
+          <p:cNvPr id="7" name="TextBox 6"/>
           <p:cNvSpPr txBox="1"/>
           <p:nvPr/>
         </p:nvSpPr>
         <p:spPr>
           <a:xfrm>
-            <a:off x="813816" y="2212848"/>
-            <a:ext cx="10515600" cy="3474720"/>
+            <a:off x="566928" y="6172200"/>
+            <a:ext cx="11045952" cy="169277"/>
           </a:xfrm>
           <a:prstGeom prst="rect">
             <a:avLst/>
@@ -5873,78 +6090,7 @@
           <a:noFill/>
         </p:spPr>
         <p:txBody>
-          <a:bodyPr wrap="square" lIns="0" rIns="0" tIns="0" bIns="0">
-            <a:spAutoFit/>
-          </a:bodyPr>
-          <a:lstStyle/>
-          <a:p>
-            <a:pPr>
-              <a:spcAft>
-                <a:spcPts val="700"/>
-              </a:spcAft>
-              <a:defRPr sz="2300" b="0">
-                <a:solidFill>
-                  <a:srgbClr val="1C1C1C"/>
-                </a:solidFill>
-                <a:latin typeface="Yu Gothic"/>
-              </a:defRPr>
-            </a:pPr>
-            <a:r>
-              <a:t>・結論：ここに事実として確認できた内容</a:t>
-            </a:r>
-          </a:p>
-          <a:p>
-            <a:pPr>
-              <a:spcAft>
-                <a:spcPts val="700"/>
-              </a:spcAft>
-              <a:defRPr sz="2300" b="0">
-                <a:solidFill>
-                  <a:srgbClr val="1C1C1C"/>
-                </a:solidFill>
-                <a:latin typeface="Yu Gothic"/>
-              </a:defRPr>
-            </a:pPr>
-            <a:r>
-              <a:t>・技術的背景：どうして重要なのか</a:t>
-            </a:r>
-          </a:p>
-          <a:p>
-            <a:pPr>
-              <a:spcAft>
-                <a:spcPts val="700"/>
-              </a:spcAft>
-              <a:defRPr sz="2300" b="0">
-                <a:solidFill>
-                  <a:srgbClr val="1C1C1C"/>
-                </a:solidFill>
-                <a:latin typeface="Yu Gothic"/>
-              </a:defRPr>
-            </a:pPr>
-            <a:r>
-              <a:t>・発表者の評価：事実とは明確に分ける</a:t>
-            </a:r>
-          </a:p>
-        </p:txBody>
-      </p:sp>
-      <p:sp>
-        <p:nvSpPr>
-          <p:cNvPr id="7" name="TextBox 6"/>
-          <p:cNvSpPr txBox="1"/>
-          <p:nvPr/>
-        </p:nvSpPr>
-        <p:spPr>
-          <a:xfrm>
-            <a:off x="813816" y="5989320"/>
-            <a:ext cx="10424160" cy="274320"/>
-          </a:xfrm>
-          <a:prstGeom prst="rect">
-            <a:avLst/>
-          </a:prstGeom>
-          <a:noFill/>
-        </p:spPr>
-        <p:txBody>
-          <a:bodyPr wrap="square" lIns="0" rIns="0" tIns="0" bIns="0">
+          <a:bodyPr wrap="square" lIns="0" tIns="0" rIns="0" bIns="0">
             <a:spAutoFit/>
           </a:bodyPr>
           <a:lstStyle/>
@@ -5955,7 +6101,7 @@
               </a:spcAft>
               <a:defRPr sz="1100" b="0">
                 <a:solidFill>
-                  <a:srgbClr val="696969"/>
+                  <a:srgbClr val="5B6B8A"/>
                 </a:solidFill>
                 <a:latin typeface="Yu Gothic"/>
               </a:defRPr>
@@ -5963,6 +6109,7 @@
             <a:r>
               <a:t>出典：実際の一次ソースURL / 発表日</a:t>
             </a:r>
+            <a:endParaRPr lang="ja-JP" altLang="en-US"/>
           </a:p>
         </p:txBody>
       </p:sp>
@@ -5974,8 +6121,8 @@
 </p:sld>
 </file>
 
-<file path=ppt/slides/slide4.xml><?xml version="1.0" encoding="utf-8"?>
-<p:sld xmlns:a="http://schemas.openxmlformats.org/drawingml/2006/main" xmlns:p="http://schemas.openxmlformats.org/presentationml/2006/main" xmlns:r="http://schemas.openxmlformats.org/officeDocument/2006/relationships">
+<file path=ppt/slides/slide5.xml><?xml version="1.0" encoding="utf-8"?>
+<p:sld xmlns:a="http://schemas.openxmlformats.org/drawingml/2006/main" xmlns:r="http://schemas.openxmlformats.org/officeDocument/2006/relationships" xmlns:p="http://schemas.openxmlformats.org/presentationml/2006/main">
   <p:cSld>
     <p:bg>
       <p:bgPr>
@@ -5991,7 +6138,14 @@
         <p:cNvGrpSpPr/>
         <p:nvPr/>
       </p:nvGrpSpPr>
-      <p:grpSpPr/>
+      <p:grpSpPr>
+        <a:xfrm>
+          <a:off x="0" y="0"/>
+          <a:ext cx="0" cy="0"/>
+          <a:chOff x="0" y="0"/>
+          <a:chExt cx="0" cy="0"/>
+        </a:xfrm>
+      </p:grpSpPr>
       <p:sp>
         <p:nvSpPr>
           <p:cNvPr id="2" name="TextBox 1"/>
@@ -6001,7 +6155,7 @@
         <p:spPr>
           <a:xfrm>
             <a:off x="566928" y="329184"/>
-            <a:ext cx="10927080" cy="594360"/>
+            <a:ext cx="10927080" cy="461665"/>
           </a:xfrm>
           <a:prstGeom prst="rect">
             <a:avLst/>
@@ -6009,7 +6163,7 @@
           <a:noFill/>
         </p:spPr>
         <p:txBody>
-          <a:bodyPr wrap="square" lIns="0" rIns="0" tIns="0" bIns="0">
+          <a:bodyPr wrap="square" lIns="0" tIns="0" rIns="0" bIns="0">
             <a:spAutoFit/>
           </a:bodyPr>
           <a:lstStyle/>
@@ -6020,7 +6174,7 @@
               </a:spcAft>
               <a:defRPr sz="3000" b="1">
                 <a:solidFill>
-                  <a:srgbClr val="C00000"/>
+                  <a:srgbClr val="0050E6"/>
                 </a:solidFill>
                 <a:latin typeface="Yu Gothic"/>
               </a:defRPr>
@@ -6028,6 +6182,7 @@
             <a:r>
               <a:t>公式資料・報道写真・記事画面の実画像</a:t>
             </a:r>
+            <a:endParaRPr lang="ja-JP" altLang="en-US"/>
           </a:p>
         </p:txBody>
       </p:sp>
@@ -6046,7 +6201,7 @@
             <a:avLst/>
           </a:prstGeom>
           <a:solidFill>
-            <a:srgbClr val="C00000"/>
+            <a:srgbClr val="FFB800"/>
           </a:solidFill>
           <a:ln>
             <a:noFill/>
@@ -6071,45 +6226,7 @@
           <a:lstStyle/>
           <a:p>
             <a:pPr algn="ctr"/>
-          </a:p>
-        </p:txBody>
-      </p:sp>
-      <p:sp>
-        <p:nvSpPr>
-          <p:cNvPr id="4" name="TextBox 3"/>
-          <p:cNvSpPr txBox="1"/>
-          <p:nvPr/>
-        </p:nvSpPr>
-        <p:spPr>
-          <a:xfrm>
-            <a:off x="566928" y="6492240"/>
-            <a:ext cx="10789920" cy="201168"/>
-          </a:xfrm>
-          <a:prstGeom prst="rect">
-            <a:avLst/>
-          </a:prstGeom>
-          <a:noFill/>
-        </p:spPr>
-        <p:txBody>
-          <a:bodyPr wrap="square" lIns="0" rIns="0" tIns="0" bIns="0">
-            <a:spAutoFit/>
-          </a:bodyPr>
-          <a:lstStyle/>
-          <a:p>
-            <a:pPr>
-              <a:spcAft>
-                <a:spcPts val="700"/>
-              </a:spcAft>
-              <a:defRPr sz="900" b="0">
-                <a:solidFill>
-                  <a:srgbClr val="696969"/>
-                </a:solidFill>
-                <a:latin typeface="Yu Gothic"/>
-              </a:defRPr>
-            </a:pPr>
-            <a:r>
-              <a:t>Weekly IT News！  •  レイアウト見本（実際の内容に差し替え）</a:t>
-            </a:r>
+            <a:endParaRPr/>
           </a:p>
         </p:txBody>
       </p:sp>
@@ -6121,14 +6238,14 @@
         </p:nvSpPr>
         <p:spPr>
           <a:xfrm>
-            <a:off x="713232" y="1280160"/>
-            <a:ext cx="10735056" cy="4389120"/>
+            <a:off x="566928" y="1280160"/>
+            <a:ext cx="11045952" cy="4297680"/>
           </a:xfrm>
           <a:prstGeom prst="rect">
             <a:avLst/>
           </a:prstGeom>
           <a:solidFill>
-            <a:srgbClr val="F1F2F4"/>
+            <a:srgbClr val="EAF2FF"/>
           </a:solidFill>
           <a:ln>
             <a:noFill/>
@@ -6153,6 +6270,7 @@
           <a:lstStyle/>
           <a:p>
             <a:pPr algn="ctr"/>
+            <a:endParaRPr/>
           </a:p>
         </p:txBody>
       </p:sp>
@@ -6164,8 +6282,8 @@
         </p:nvSpPr>
         <p:spPr>
           <a:xfrm>
-            <a:off x="1417320" y="3035808"/>
-            <a:ext cx="9418320" cy="1005840"/>
+            <a:off x="1380744" y="3017520"/>
+            <a:ext cx="9418320" cy="828432"/>
           </a:xfrm>
           <a:prstGeom prst="rect">
             <a:avLst/>
@@ -6173,7 +6291,7 @@
           <a:noFill/>
         </p:spPr>
         <p:txBody>
-          <a:bodyPr wrap="square" lIns="0" rIns="0" tIns="0" bIns="0">
+          <a:bodyPr wrap="square" lIns="0" tIns="0" rIns="0" bIns="0">
             <a:spAutoFit/>
           </a:bodyPr>
           <a:lstStyle/>
@@ -6184,7 +6302,7 @@
               </a:spcAft>
               <a:defRPr sz="2400" b="0">
                 <a:solidFill>
-                  <a:srgbClr val="696969"/>
+                  <a:srgbClr val="5B6B8A"/>
                 </a:solidFill>
                 <a:latin typeface="Yu Gothic"/>
               </a:defRPr>
@@ -6192,6 +6310,7 @@
             <a:r>
               <a:t>画像プレースホルダー</a:t>
             </a:r>
+            <a:endParaRPr lang="ja-JP" altLang="en-US"/>
           </a:p>
           <a:p>
             <a:pPr algn="ctr">
@@ -6200,7 +6319,7 @@
               </a:spcAft>
               <a:defRPr sz="2400" b="0">
                 <a:solidFill>
-                  <a:srgbClr val="696969"/>
+                  <a:srgbClr val="5B6B8A"/>
                 </a:solidFill>
                 <a:latin typeface="Yu Gothic"/>
               </a:defRPr>
@@ -6208,6 +6327,7 @@
             <a:r>
               <a:t>（実際のニュース画像やキャプチャだけを差し込む）</a:t>
             </a:r>
+            <a:endParaRPr lang="ja-JP" altLang="en-US"/>
           </a:p>
         </p:txBody>
       </p:sp>
@@ -6219,8 +6339,8 @@
         </p:nvSpPr>
         <p:spPr>
           <a:xfrm>
-            <a:off x="731520" y="5760720"/>
-            <a:ext cx="10789920" cy="402336"/>
+            <a:off x="566928" y="5715000"/>
+            <a:ext cx="11045952" cy="292388"/>
           </a:xfrm>
           <a:prstGeom prst="rect">
             <a:avLst/>
@@ -6228,7 +6348,7 @@
           <a:noFill/>
         </p:spPr>
         <p:txBody>
-          <a:bodyPr wrap="square" lIns="0" rIns="0" tIns="0" bIns="0">
+          <a:bodyPr wrap="square" lIns="0" tIns="0" rIns="0" bIns="0">
             <a:spAutoFit/>
           </a:bodyPr>
           <a:lstStyle/>
@@ -6239,7 +6359,7 @@
               </a:spcAft>
               <a:defRPr sz="1900" b="0">
                 <a:solidFill>
-                  <a:srgbClr val="1C1C1C"/>
+                  <a:srgbClr val="0A1A3A"/>
                 </a:solidFill>
                 <a:latin typeface="Yu Gothic"/>
               </a:defRPr>
@@ -6247,6 +6367,7 @@
             <a:r>
               <a:t>この画像が裏付けること・見るべき箇所を一文で</a:t>
             </a:r>
+            <a:endParaRPr lang="ja-JP" altLang="en-US"/>
           </a:p>
         </p:txBody>
       </p:sp>
@@ -6258,8 +6379,8 @@
         </p:nvSpPr>
         <p:spPr>
           <a:xfrm>
-            <a:off x="731520" y="6236208"/>
-            <a:ext cx="10789920" cy="237744"/>
+            <a:off x="566928" y="6172200"/>
+            <a:ext cx="11045952" cy="169277"/>
           </a:xfrm>
           <a:prstGeom prst="rect">
             <a:avLst/>
@@ -6267,7 +6388,7 @@
           <a:noFill/>
         </p:spPr>
         <p:txBody>
-          <a:bodyPr wrap="square" lIns="0" rIns="0" tIns="0" bIns="0">
+          <a:bodyPr wrap="square" lIns="0" tIns="0" rIns="0" bIns="0">
             <a:spAutoFit/>
           </a:bodyPr>
           <a:lstStyle/>
@@ -6278,7 +6399,7 @@
               </a:spcAft>
               <a:defRPr sz="1100" b="0">
                 <a:solidFill>
-                  <a:srgbClr val="696969"/>
+                  <a:srgbClr val="5B6B8A"/>
                 </a:solidFill>
                 <a:latin typeface="Yu Gothic"/>
               </a:defRPr>
@@ -6286,6 +6407,7 @@
             <a:r>
               <a:t>画像出典URL・提供元・画像作成者・撮影日</a:t>
             </a:r>
+            <a:endParaRPr lang="ja-JP" altLang="en-US"/>
           </a:p>
         </p:txBody>
       </p:sp>
@@ -6297,8 +6419,8 @@
 </p:sld>
 </file>
 
-<file path=ppt/slides/slide5.xml><?xml version="1.0" encoding="utf-8"?>
-<p:sld xmlns:a="http://schemas.openxmlformats.org/drawingml/2006/main" xmlns:p="http://schemas.openxmlformats.org/presentationml/2006/main" xmlns:r="http://schemas.openxmlformats.org/officeDocument/2006/relationships">
+<file path=ppt/slides/slide6.xml><?xml version="1.0" encoding="utf-8"?>
+<p:sld xmlns:a="http://schemas.openxmlformats.org/drawingml/2006/main" xmlns:r="http://schemas.openxmlformats.org/officeDocument/2006/relationships" xmlns:p="http://schemas.openxmlformats.org/presentationml/2006/main">
   <p:cSld>
     <p:bg>
       <p:bgPr>
@@ -6314,7 +6436,14 @@
         <p:cNvGrpSpPr/>
         <p:nvPr/>
       </p:nvGrpSpPr>
-      <p:grpSpPr/>
+      <p:grpSpPr>
+        <a:xfrm>
+          <a:off x="0" y="0"/>
+          <a:ext cx="0" cy="0"/>
+          <a:chOff x="0" y="0"/>
+          <a:chExt cx="0" cy="0"/>
+        </a:xfrm>
+      </p:grpSpPr>
       <p:sp>
         <p:nvSpPr>
           <p:cNvPr id="2" name="TextBox 1"/>
@@ -6324,7 +6453,7 @@
         <p:spPr>
           <a:xfrm>
             <a:off x="566928" y="329184"/>
-            <a:ext cx="10927080" cy="594360"/>
+            <a:ext cx="10927080" cy="461665"/>
           </a:xfrm>
           <a:prstGeom prst="rect">
             <a:avLst/>
@@ -6332,7 +6461,7 @@
           <a:noFill/>
         </p:spPr>
         <p:txBody>
-          <a:bodyPr wrap="square" lIns="0" rIns="0" tIns="0" bIns="0">
+          <a:bodyPr wrap="square" lIns="0" tIns="0" rIns="0" bIns="0">
             <a:spAutoFit/>
           </a:bodyPr>
           <a:lstStyle/>
@@ -6343,7 +6472,7 @@
               </a:spcAft>
               <a:defRPr sz="3000" b="1">
                 <a:solidFill>
-                  <a:srgbClr val="C00000"/>
+                  <a:srgbClr val="0050E6"/>
                 </a:solidFill>
                 <a:latin typeface="Yu Gothic"/>
               </a:defRPr>
@@ -6351,6 +6480,7 @@
             <a:r>
               <a:t>技術解説：編集可能な模式図</a:t>
             </a:r>
+            <a:endParaRPr lang="ja-JP" altLang="en-US"/>
           </a:p>
         </p:txBody>
       </p:sp>
@@ -6369,7 +6499,7 @@
             <a:avLst/>
           </a:prstGeom>
           <a:solidFill>
-            <a:srgbClr val="C00000"/>
+            <a:srgbClr val="FFB800"/>
           </a:solidFill>
           <a:ln>
             <a:noFill/>
@@ -6394,19 +6524,20 @@
           <a:lstStyle/>
           <a:p>
             <a:pPr algn="ctr"/>
-          </a:p>
-        </p:txBody>
-      </p:sp>
-      <p:sp>
-        <p:nvSpPr>
-          <p:cNvPr id="4" name="TextBox 3"/>
+            <a:endParaRPr/>
+          </a:p>
+        </p:txBody>
+      </p:sp>
+      <p:sp>
+        <p:nvSpPr>
+          <p:cNvPr id="5" name="TextBox 4"/>
           <p:cNvSpPr txBox="1"/>
           <p:nvPr/>
         </p:nvSpPr>
         <p:spPr>
           <a:xfrm>
-            <a:off x="566928" y="6492240"/>
-            <a:ext cx="10789920" cy="201168"/>
+            <a:off x="566928" y="1316736"/>
+            <a:ext cx="10607040" cy="292388"/>
           </a:xfrm>
           <a:prstGeom prst="rect">
             <a:avLst/>
@@ -6414,46 +6545,7 @@
           <a:noFill/>
         </p:spPr>
         <p:txBody>
-          <a:bodyPr wrap="square" lIns="0" rIns="0" tIns="0" bIns="0">
-            <a:spAutoFit/>
-          </a:bodyPr>
-          <a:lstStyle/>
-          <a:p>
-            <a:pPr>
-              <a:spcAft>
-                <a:spcPts val="700"/>
-              </a:spcAft>
-              <a:defRPr sz="900" b="0">
-                <a:solidFill>
-                  <a:srgbClr val="696969"/>
-                </a:solidFill>
-                <a:latin typeface="Yu Gothic"/>
-              </a:defRPr>
-            </a:pPr>
-            <a:r>
-              <a:t>Weekly IT News！  •  レイアウト見本（実際の内容に差し替え）</a:t>
-            </a:r>
-          </a:p>
-        </p:txBody>
-      </p:sp>
-      <p:sp>
-        <p:nvSpPr>
-          <p:cNvPr id="5" name="TextBox 4"/>
-          <p:cNvSpPr txBox="1"/>
-          <p:nvPr/>
-        </p:nvSpPr>
-        <p:spPr>
-          <a:xfrm>
-            <a:off x="731520" y="1316736"/>
-            <a:ext cx="10607040" cy="457200"/>
-          </a:xfrm>
-          <a:prstGeom prst="rect">
-            <a:avLst/>
-          </a:prstGeom>
-          <a:noFill/>
-        </p:spPr>
-        <p:txBody>
-          <a:bodyPr wrap="square" lIns="0" rIns="0" tIns="0" bIns="0">
+          <a:bodyPr wrap="square" lIns="0" tIns="0" rIns="0" bIns="0">
             <a:spAutoFit/>
           </a:bodyPr>
           <a:lstStyle/>
@@ -6464,7 +6556,7 @@
               </a:spcAft>
               <a:defRPr sz="1900" b="0">
                 <a:solidFill>
-                  <a:srgbClr val="1C1C1C"/>
+                  <a:srgbClr val="0A1A3A"/>
                 </a:solidFill>
                 <a:latin typeface="Yu Gothic"/>
               </a:defRPr>
@@ -6472,6 +6564,7 @@
             <a:r>
               <a:t>図はネイティブ図形で作成し、入力から結果の意味を明示する</a:t>
             </a:r>
+            <a:endParaRPr lang="ja-JP" altLang="en-US"/>
           </a:p>
         </p:txBody>
       </p:sp>
@@ -6490,7 +6583,7 @@
             <a:avLst/>
           </a:prstGeom>
           <a:solidFill>
-            <a:srgbClr val="F1F2F4"/>
+            <a:srgbClr val="EAF2FF"/>
           </a:solidFill>
           <a:ln>
             <a:noFill/>
@@ -6515,6 +6608,7 @@
           <a:lstStyle/>
           <a:p>
             <a:pPr algn="ctr"/>
+            <a:endParaRPr/>
           </a:p>
         </p:txBody>
       </p:sp>
@@ -6527,7 +6621,7 @@
         <p:spPr>
           <a:xfrm>
             <a:off x="960120" y="3154680"/>
-            <a:ext cx="2560320" cy="438912"/>
+            <a:ext cx="2560320" cy="323165"/>
           </a:xfrm>
           <a:prstGeom prst="rect">
             <a:avLst/>
@@ -6535,7 +6629,7 @@
           <a:noFill/>
         </p:spPr>
         <p:txBody>
-          <a:bodyPr wrap="square" lIns="0" rIns="0" tIns="0" bIns="0">
+          <a:bodyPr wrap="square" lIns="0" tIns="0" rIns="0" bIns="0">
             <a:spAutoFit/>
           </a:bodyPr>
           <a:lstStyle/>
@@ -6546,7 +6640,7 @@
               </a:spcAft>
               <a:defRPr sz="2100" b="1">
                 <a:solidFill>
-                  <a:srgbClr val="1C1C1C"/>
+                  <a:srgbClr val="0A1A3A"/>
                 </a:solidFill>
                 <a:latin typeface="Yu Gothic"/>
               </a:defRPr>
@@ -6554,6 +6648,7 @@
             <a:r>
               <a:t>入力 / 起点</a:t>
             </a:r>
+            <a:endParaRPr lang="ja-JP" altLang="en-US"/>
           </a:p>
         </p:txBody>
       </p:sp>
@@ -6572,7 +6667,7 @@
             <a:avLst/>
           </a:prstGeom>
           <a:solidFill>
-            <a:srgbClr val="F1F2F4"/>
+            <a:srgbClr val="EAF2FF"/>
           </a:solidFill>
           <a:ln>
             <a:noFill/>
@@ -6597,6 +6692,7 @@
           <a:lstStyle/>
           <a:p>
             <a:pPr algn="ctr"/>
+            <a:endParaRPr/>
           </a:p>
         </p:txBody>
       </p:sp>
@@ -6609,7 +6705,7 @@
         <p:spPr>
           <a:xfrm>
             <a:off x="4800600" y="3154680"/>
-            <a:ext cx="2560320" cy="438912"/>
+            <a:ext cx="2560320" cy="323165"/>
           </a:xfrm>
           <a:prstGeom prst="rect">
             <a:avLst/>
@@ -6617,7 +6713,7 @@
           <a:noFill/>
         </p:spPr>
         <p:txBody>
-          <a:bodyPr wrap="square" lIns="0" rIns="0" tIns="0" bIns="0">
+          <a:bodyPr wrap="square" lIns="0" tIns="0" rIns="0" bIns="0">
             <a:spAutoFit/>
           </a:bodyPr>
           <a:lstStyle/>
@@ -6628,7 +6724,7 @@
               </a:spcAft>
               <a:defRPr sz="2100" b="1">
                 <a:solidFill>
-                  <a:srgbClr val="1C1C1C"/>
+                  <a:srgbClr val="0A1A3A"/>
                 </a:solidFill>
                 <a:latin typeface="Yu Gothic"/>
               </a:defRPr>
@@ -6636,6 +6732,7 @@
             <a:r>
               <a:t>処理 / 技術</a:t>
             </a:r>
+            <a:endParaRPr lang="ja-JP" altLang="en-US"/>
           </a:p>
         </p:txBody>
       </p:sp>
@@ -6654,7 +6751,7 @@
             <a:avLst/>
           </a:prstGeom>
           <a:solidFill>
-            <a:srgbClr val="F1F2F4"/>
+            <a:srgbClr val="EAF2FF"/>
           </a:solidFill>
           <a:ln>
             <a:noFill/>
@@ -6679,6 +6776,7 @@
           <a:lstStyle/>
           <a:p>
             <a:pPr algn="ctr"/>
+            <a:endParaRPr/>
           </a:p>
         </p:txBody>
       </p:sp>
@@ -6691,7 +6789,7 @@
         <p:spPr>
           <a:xfrm>
             <a:off x="8549640" y="3154680"/>
-            <a:ext cx="2560320" cy="438912"/>
+            <a:ext cx="2560320" cy="323165"/>
           </a:xfrm>
           <a:prstGeom prst="rect">
             <a:avLst/>
@@ -6699,7 +6797,7 @@
           <a:noFill/>
         </p:spPr>
         <p:txBody>
-          <a:bodyPr wrap="square" lIns="0" rIns="0" tIns="0" bIns="0">
+          <a:bodyPr wrap="square" lIns="0" tIns="0" rIns="0" bIns="0">
             <a:spAutoFit/>
           </a:bodyPr>
           <a:lstStyle/>
@@ -6710,7 +6808,7 @@
               </a:spcAft>
               <a:defRPr sz="2100" b="1">
                 <a:solidFill>
-                  <a:srgbClr val="1C1C1C"/>
+                  <a:srgbClr val="0A1A3A"/>
                 </a:solidFill>
                 <a:latin typeface="Yu Gothic"/>
               </a:defRPr>
@@ -6718,6 +6816,7 @@
             <a:r>
               <a:t>結果 / 影響</a:t>
             </a:r>
+            <a:endParaRPr lang="ja-JP" altLang="en-US"/>
           </a:p>
         </p:txBody>
       </p:sp>
@@ -6738,7 +6837,7 @@
           <a:noFill/>
         </p:spPr>
         <p:txBody>
-          <a:bodyPr wrap="square" lIns="0" rIns="0" tIns="0" bIns="0">
+          <a:bodyPr wrap="square" lIns="0" tIns="0" rIns="0" bIns="0">
             <a:spAutoFit/>
           </a:bodyPr>
           <a:lstStyle/>
@@ -6749,7 +6848,7 @@
               </a:spcAft>
               <a:defRPr sz="3000" b="1">
                 <a:solidFill>
-                  <a:srgbClr val="C00000"/>
+                  <a:srgbClr val="0050E6"/>
                 </a:solidFill>
                 <a:latin typeface="Yu Gothic"/>
               </a:defRPr>
@@ -6757,6 +6856,7 @@
             <a:r>
               <a:t>→</a:t>
             </a:r>
+            <a:endParaRPr lang="ja-JP" altLang="en-US"/>
           </a:p>
         </p:txBody>
       </p:sp>
@@ -6777,7 +6877,7 @@
           <a:noFill/>
         </p:spPr>
         <p:txBody>
-          <a:bodyPr wrap="square" lIns="0" rIns="0" tIns="0" bIns="0">
+          <a:bodyPr wrap="square" lIns="0" tIns="0" rIns="0" bIns="0">
             <a:spAutoFit/>
           </a:bodyPr>
           <a:lstStyle/>
@@ -6788,7 +6888,7 @@
               </a:spcAft>
               <a:defRPr sz="3000" b="1">
                 <a:solidFill>
-                  <a:srgbClr val="C00000"/>
+                  <a:srgbClr val="0050E6"/>
                 </a:solidFill>
                 <a:latin typeface="Yu Gothic"/>
               </a:defRPr>
@@ -6796,6 +6896,7 @@
             <a:r>
               <a:t>→</a:t>
             </a:r>
+            <a:endParaRPr lang="ja-JP" altLang="en-US"/>
           </a:p>
         </p:txBody>
       </p:sp>
@@ -6807,8 +6908,8 @@
         </p:nvSpPr>
         <p:spPr>
           <a:xfrm>
-            <a:off x="713232" y="5943600"/>
-            <a:ext cx="10607040" cy="411480"/>
+            <a:off x="566928" y="6172200"/>
+            <a:ext cx="11045952" cy="200055"/>
           </a:xfrm>
           <a:prstGeom prst="rect">
             <a:avLst/>
@@ -6816,7 +6917,7 @@
           <a:noFill/>
         </p:spPr>
         <p:txBody>
-          <a:bodyPr wrap="square" lIns="0" rIns="0" tIns="0" bIns="0">
+          <a:bodyPr wrap="square" lIns="0" tIns="0" rIns="0" bIns="0">
             <a:spAutoFit/>
           </a:bodyPr>
           <a:lstStyle/>
@@ -6827,7 +6928,7 @@
               </a:spcAft>
               <a:defRPr sz="1300" b="0">
                 <a:solidFill>
-                  <a:srgbClr val="696969"/>
+                  <a:srgbClr val="5B6B8A"/>
                 </a:solidFill>
                 <a:latin typeface="Yu Gothic"/>
               </a:defRPr>
@@ -6835,6 +6936,7 @@
             <a:r>
               <a:t>根拠となる技術資料URL、仮定、図の適用範囲</a:t>
             </a:r>
+            <a:endParaRPr lang="ja-JP" altLang="en-US"/>
           </a:p>
         </p:txBody>
       </p:sp>
@@ -6846,8 +6948,8 @@
 </p:sld>
 </file>
 
-<file path=ppt/slides/slide6.xml><?xml version="1.0" encoding="utf-8"?>
-<p:sld xmlns:a="http://schemas.openxmlformats.org/drawingml/2006/main" xmlns:p="http://schemas.openxmlformats.org/presentationml/2006/main" xmlns:r="http://schemas.openxmlformats.org/officeDocument/2006/relationships">
+<file path=ppt/slides/slide7.xml><?xml version="1.0" encoding="utf-8"?>
+<p:sld xmlns:a="http://schemas.openxmlformats.org/drawingml/2006/main" xmlns:r="http://schemas.openxmlformats.org/officeDocument/2006/relationships" xmlns:p="http://schemas.openxmlformats.org/presentationml/2006/main">
   <p:cSld>
     <p:bg>
       <p:bgPr>
@@ -6863,7 +6965,14 @@
         <p:cNvGrpSpPr/>
         <p:nvPr/>
       </p:nvGrpSpPr>
-      <p:grpSpPr/>
+      <p:grpSpPr>
+        <a:xfrm>
+          <a:off x="0" y="0"/>
+          <a:ext cx="0" cy="0"/>
+          <a:chOff x="0" y="0"/>
+          <a:chExt cx="0" cy="0"/>
+        </a:xfrm>
+      </p:grpSpPr>
       <p:sp>
         <p:nvSpPr>
           <p:cNvPr id="2" name="TextBox 1"/>
@@ -6873,7 +6982,7 @@
         <p:spPr>
           <a:xfrm>
             <a:off x="566928" y="329184"/>
-            <a:ext cx="10927080" cy="594360"/>
+            <a:ext cx="10927080" cy="461665"/>
           </a:xfrm>
           <a:prstGeom prst="rect">
             <a:avLst/>
@@ -6881,7 +6990,7 @@
           <a:noFill/>
         </p:spPr>
         <p:txBody>
-          <a:bodyPr wrap="square" lIns="0" rIns="0" tIns="0" bIns="0">
+          <a:bodyPr wrap="square" lIns="0" tIns="0" rIns="0" bIns="0">
             <a:spAutoFit/>
           </a:bodyPr>
           <a:lstStyle/>
@@ -6892,7 +7001,7 @@
               </a:spcAft>
               <a:defRPr sz="3000" b="1">
                 <a:solidFill>
-                  <a:srgbClr val="C00000"/>
+                  <a:srgbClr val="0050E6"/>
                 </a:solidFill>
                 <a:latin typeface="Yu Gothic"/>
               </a:defRPr>
@@ -6900,6 +7009,7 @@
             <a:r>
               <a:t>仕様・方式・性能の比較</a:t>
             </a:r>
+            <a:endParaRPr lang="ja-JP" altLang="en-US"/>
           </a:p>
         </p:txBody>
       </p:sp>
@@ -6918,7 +7028,7 @@
             <a:avLst/>
           </a:prstGeom>
           <a:solidFill>
-            <a:srgbClr val="C00000"/>
+            <a:srgbClr val="FFB800"/>
           </a:solidFill>
           <a:ln>
             <a:noFill/>
@@ -6943,19 +7053,20 @@
           <a:lstStyle/>
           <a:p>
             <a:pPr algn="ctr"/>
-          </a:p>
-        </p:txBody>
-      </p:sp>
-      <p:sp>
-        <p:nvSpPr>
-          <p:cNvPr id="4" name="TextBox 3"/>
+            <a:endParaRPr/>
+          </a:p>
+        </p:txBody>
+      </p:sp>
+      <p:sp>
+        <p:nvSpPr>
+          <p:cNvPr id="5" name="TextBox 4"/>
           <p:cNvSpPr txBox="1"/>
           <p:nvPr/>
         </p:nvSpPr>
         <p:spPr>
           <a:xfrm>
-            <a:off x="566928" y="6492240"/>
-            <a:ext cx="10789920" cy="201168"/>
+            <a:off x="566928" y="1234440"/>
+            <a:ext cx="10607040" cy="261610"/>
           </a:xfrm>
           <a:prstGeom prst="rect">
             <a:avLst/>
@@ -6963,46 +7074,7 @@
           <a:noFill/>
         </p:spPr>
         <p:txBody>
-          <a:bodyPr wrap="square" lIns="0" rIns="0" tIns="0" bIns="0">
-            <a:spAutoFit/>
-          </a:bodyPr>
-          <a:lstStyle/>
-          <a:p>
-            <a:pPr>
-              <a:spcAft>
-                <a:spcPts val="700"/>
-              </a:spcAft>
-              <a:defRPr sz="900" b="0">
-                <a:solidFill>
-                  <a:srgbClr val="696969"/>
-                </a:solidFill>
-                <a:latin typeface="Yu Gothic"/>
-              </a:defRPr>
-            </a:pPr>
-            <a:r>
-              <a:t>Weekly IT News！  •  レイアウト見本（実際の内容に差し替え）</a:t>
-            </a:r>
-          </a:p>
-        </p:txBody>
-      </p:sp>
-      <p:sp>
-        <p:nvSpPr>
-          <p:cNvPr id="5" name="TextBox 4"/>
-          <p:cNvSpPr txBox="1"/>
-          <p:nvPr/>
-        </p:nvSpPr>
-        <p:spPr>
-          <a:xfrm>
-            <a:off x="749808" y="1234440"/>
-            <a:ext cx="10607040" cy="448056"/>
-          </a:xfrm>
-          <a:prstGeom prst="rect">
-            <a:avLst/>
-          </a:prstGeom>
-          <a:noFill/>
-        </p:spPr>
-        <p:txBody>
-          <a:bodyPr wrap="square" lIns="0" rIns="0" tIns="0" bIns="0">
+          <a:bodyPr wrap="square" lIns="0" tIns="0" rIns="0" bIns="0">
             <a:spAutoFit/>
           </a:bodyPr>
           <a:lstStyle/>
@@ -7013,7 +7085,7 @@
               </a:spcAft>
               <a:defRPr sz="1700" b="0">
                 <a:solidFill>
-                  <a:srgbClr val="1C1C1C"/>
+                  <a:srgbClr val="0A1A3A"/>
                 </a:solidFill>
                 <a:latin typeface="Yu Gothic"/>
               </a:defRPr>
@@ -7021,6 +7093,7 @@
             <a:r>
               <a:t>比較条件・測定条件が異なる値を直接優劣として扱わない</a:t>
             </a:r>
+            <a:endParaRPr lang="ja-JP" altLang="en-US"/>
           </a:p>
         </p:txBody>
       </p:sp>
@@ -7030,10 +7103,16 @@
           <p:cNvGraphicFramePr>
             <a:graphicFrameLocks noGrp="1"/>
           </p:cNvGraphicFramePr>
-          <p:nvPr/>
+          <p:nvPr>
+            <p:extLst>
+              <p:ext uri="{D42A27DB-BD31-4B8C-83A1-F6EECF244321}">
+                <p14:modId xmlns:p14="http://schemas.microsoft.com/office/powerpoint/2010/main" val="1265166723"/>
+              </p:ext>
+            </p:extLst>
+          </p:nvPr>
         </p:nvGraphicFramePr>
         <p:xfrm>
-          <a:off x="777240" y="1984248"/>
+          <a:off x="566928" y="1828800"/>
           <a:ext cx="10698478" cy="3090672"/>
         </p:xfrm>
         <a:graphic>
@@ -7043,9 +7122,27 @@
                 <a:tableStyleId>{5C22544A-7EE6-4342-B048-85BDC9FD1C3A}</a:tableStyleId>
               </a:tblPr>
               <a:tblGrid>
-                <a:gridCol w="3200400"/>
-                <a:gridCol w="3749039"/>
-                <a:gridCol w="3749039"/>
+                <a:gridCol w="3200400">
+                  <a:extLst>
+                    <a:ext uri="{9D8B030D-6E8A-4147-A177-3AD203B41FA5}">
+                      <a16:colId xmlns:a16="http://schemas.microsoft.com/office/drawing/2014/main" val="20000"/>
+                    </a:ext>
+                  </a:extLst>
+                </a:gridCol>
+                <a:gridCol w="3749039">
+                  <a:extLst>
+                    <a:ext uri="{9D8B030D-6E8A-4147-A177-3AD203B41FA5}">
+                      <a16:colId xmlns:a16="http://schemas.microsoft.com/office/drawing/2014/main" val="20001"/>
+                    </a:ext>
+                  </a:extLst>
+                </a:gridCol>
+                <a:gridCol w="3749039">
+                  <a:extLst>
+                    <a:ext uri="{9D8B030D-6E8A-4147-A177-3AD203B41FA5}">
+                      <a16:colId xmlns:a16="http://schemas.microsoft.com/office/drawing/2014/main" val="20002"/>
+                    </a:ext>
+                  </a:extLst>
+                </a:gridCol>
               </a:tblGrid>
               <a:tr h="772668">
                 <a:tc>
@@ -7056,19 +7153,20 @@
                       <a:pPr>
                         <a:defRPr sz="1900" b="1">
                           <a:solidFill>
-                            <a:srgbClr val="C00000"/>
+                            <a:srgbClr val="0050E6"/>
                           </a:solidFill>
                           <a:latin typeface="Yu Gothic"/>
                         </a:defRPr>
                       </a:pPr>
                       <a:r>
+                        <a:rPr lang="ja-JP" altLang="en-US"/>
                         <a:t>比較観点</a:t>
                       </a:r>
                     </a:p>
                   </a:txBody>
                   <a:tcPr marL="146304">
                     <a:solidFill>
-                      <a:srgbClr val="F1F2F4"/>
+                      <a:srgbClr val="EAF2FF"/>
                     </a:solidFill>
                   </a:tcPr>
                 </a:tc>
@@ -7080,19 +7178,24 @@
                       <a:pPr>
                         <a:defRPr sz="1900" b="1">
                           <a:solidFill>
-                            <a:srgbClr val="C00000"/>
+                            <a:srgbClr val="0050E6"/>
                           </a:solidFill>
                           <a:latin typeface="Yu Gothic"/>
                         </a:defRPr>
                       </a:pPr>
                       <a:r>
-                        <a:t>A方式</a:t>
+                        <a:rPr lang="en-US"/>
+                        <a:t>A</a:t>
+                      </a:r>
+                      <a:r>
+                        <a:rPr lang="ja-JP" altLang="en-US"/>
+                        <a:t>方式</a:t>
                       </a:r>
                     </a:p>
                   </a:txBody>
                   <a:tcPr marL="146304">
                     <a:solidFill>
-                      <a:srgbClr val="F1F2F4"/>
+                      <a:srgbClr val="EAF2FF"/>
                     </a:solidFill>
                   </a:tcPr>
                 </a:tc>
@@ -7104,22 +7207,32 @@
                       <a:pPr>
                         <a:defRPr sz="1900" b="1">
                           <a:solidFill>
-                            <a:srgbClr val="C00000"/>
+                            <a:srgbClr val="0050E6"/>
                           </a:solidFill>
                           <a:latin typeface="Yu Gothic"/>
                         </a:defRPr>
                       </a:pPr>
                       <a:r>
-                        <a:t>B方式</a:t>
+                        <a:rPr lang="en-US"/>
+                        <a:t>B</a:t>
+                      </a:r>
+                      <a:r>
+                        <a:rPr lang="ja-JP" altLang="en-US"/>
+                        <a:t>方式</a:t>
                       </a:r>
                     </a:p>
                   </a:txBody>
                   <a:tcPr marL="146304">
                     <a:solidFill>
-                      <a:srgbClr val="F1F2F4"/>
+                      <a:srgbClr val="EAF2FF"/>
                     </a:solidFill>
                   </a:tcPr>
                 </a:tc>
+                <a:extLst>
+                  <a:ext uri="{0D108BD9-81ED-4DB2-BD59-A6C34878D82A}">
+                    <a16:rowId xmlns:a16="http://schemas.microsoft.com/office/drawing/2014/main" val="10000"/>
+                  </a:ext>
+                </a:extLst>
               </a:tr>
               <a:tr h="772668">
                 <a:tc>
@@ -7130,12 +7243,13 @@
                       <a:pPr>
                         <a:defRPr sz="1900" b="0">
                           <a:solidFill>
-                            <a:srgbClr val="1C1C1C"/>
+                            <a:srgbClr val="0A1A3A"/>
                           </a:solidFill>
                           <a:latin typeface="Yu Gothic"/>
                         </a:defRPr>
                       </a:pPr>
                       <a:r>
+                        <a:rPr lang="ja-JP" altLang="en-US"/>
                         <a:t>目的</a:t>
                       </a:r>
                     </a:p>
@@ -7154,13 +7268,18 @@
                       <a:pPr>
                         <a:defRPr sz="1900" b="0">
                           <a:solidFill>
-                            <a:srgbClr val="1C1C1C"/>
+                            <a:srgbClr val="0A1A3A"/>
                           </a:solidFill>
                           <a:latin typeface="Yu Gothic"/>
                         </a:defRPr>
                       </a:pPr>
                       <a:r>
-                        <a:t>比較対象A</a:t>
+                        <a:rPr lang="ja-JP" altLang="en-US"/>
+                        <a:t>比較対象</a:t>
+                      </a:r>
+                      <a:r>
+                        <a:rPr lang="en-US"/>
+                        <a:t>A</a:t>
                       </a:r>
                     </a:p>
                   </a:txBody>
@@ -7178,13 +7297,18 @@
                       <a:pPr>
                         <a:defRPr sz="1900" b="0">
                           <a:solidFill>
-                            <a:srgbClr val="1C1C1C"/>
+                            <a:srgbClr val="0A1A3A"/>
                           </a:solidFill>
                           <a:latin typeface="Yu Gothic"/>
                         </a:defRPr>
                       </a:pPr>
                       <a:r>
-                        <a:t>比較対象B</a:t>
+                        <a:rPr lang="ja-JP" altLang="en-US"/>
+                        <a:t>比較対象</a:t>
+                      </a:r>
+                      <a:r>
+                        <a:rPr lang="en-US"/>
+                        <a:t>B</a:t>
                       </a:r>
                     </a:p>
                   </a:txBody>
@@ -7194,6 +7318,11 @@
                     </a:solidFill>
                   </a:tcPr>
                 </a:tc>
+                <a:extLst>
+                  <a:ext uri="{0D108BD9-81ED-4DB2-BD59-A6C34878D82A}">
+                    <a16:rowId xmlns:a16="http://schemas.microsoft.com/office/drawing/2014/main" val="10001"/>
+                  </a:ext>
+                </a:extLst>
               </a:tr>
               <a:tr h="772668">
                 <a:tc>
@@ -7204,12 +7333,13 @@
                       <a:pPr>
                         <a:defRPr sz="1900" b="0">
                           <a:solidFill>
-                            <a:srgbClr val="1C1C1C"/>
+                            <a:srgbClr val="0A1A3A"/>
                           </a:solidFill>
                           <a:latin typeface="Yu Gothic"/>
                         </a:defRPr>
                       </a:pPr>
                       <a:r>
+                        <a:rPr lang="ja-JP" altLang="en-US"/>
                         <a:t>特徴</a:t>
                       </a:r>
                     </a:p>
@@ -7228,12 +7358,13 @@
                       <a:pPr>
                         <a:defRPr sz="1900" b="0">
                           <a:solidFill>
-                            <a:srgbClr val="1C1C1C"/>
+                            <a:srgbClr val="0A1A3A"/>
                           </a:solidFill>
                           <a:latin typeface="Yu Gothic"/>
                         </a:defRPr>
                       </a:pPr>
                       <a:r>
+                        <a:rPr lang="ja-JP" altLang="en-US"/>
                         <a:t>条件・根拠を記載</a:t>
                       </a:r>
                     </a:p>
@@ -7252,12 +7383,13 @@
                       <a:pPr>
                         <a:defRPr sz="1900" b="0">
                           <a:solidFill>
-                            <a:srgbClr val="1C1C1C"/>
+                            <a:srgbClr val="0A1A3A"/>
                           </a:solidFill>
                           <a:latin typeface="Yu Gothic"/>
                         </a:defRPr>
                       </a:pPr>
                       <a:r>
+                        <a:rPr lang="ja-JP" altLang="en-US"/>
                         <a:t>条件・根拠を記載</a:t>
                       </a:r>
                     </a:p>
@@ -7268,6 +7400,11 @@
                     </a:solidFill>
                   </a:tcPr>
                 </a:tc>
+                <a:extLst>
+                  <a:ext uri="{0D108BD9-81ED-4DB2-BD59-A6C34878D82A}">
+                    <a16:rowId xmlns:a16="http://schemas.microsoft.com/office/drawing/2014/main" val="10002"/>
+                  </a:ext>
+                </a:extLst>
               </a:tr>
               <a:tr h="772668">
                 <a:tc>
@@ -7278,12 +7415,13 @@
                       <a:pPr>
                         <a:defRPr sz="1900" b="0">
                           <a:solidFill>
-                            <a:srgbClr val="1C1C1C"/>
+                            <a:srgbClr val="0A1A3A"/>
                           </a:solidFill>
                           <a:latin typeface="Yu Gothic"/>
                         </a:defRPr>
                       </a:pPr>
                       <a:r>
+                        <a:rPr lang="ja-JP" altLang="en-US"/>
                         <a:t>制約</a:t>
                       </a:r>
                     </a:p>
@@ -7302,12 +7440,13 @@
                       <a:pPr>
                         <a:defRPr sz="1900" b="0">
                           <a:solidFill>
-                            <a:srgbClr val="1C1C1C"/>
+                            <a:srgbClr val="0A1A3A"/>
                           </a:solidFill>
                           <a:latin typeface="Yu Gothic"/>
                         </a:defRPr>
                       </a:pPr>
                       <a:r>
+                        <a:rPr lang="ja-JP" altLang="en-US"/>
                         <a:t>測定環境・制限</a:t>
                       </a:r>
                     </a:p>
@@ -7326,12 +7465,13 @@
                       <a:pPr>
                         <a:defRPr sz="1900" b="0">
                           <a:solidFill>
-                            <a:srgbClr val="1C1C1C"/>
+                            <a:srgbClr val="0A1A3A"/>
                           </a:solidFill>
                           <a:latin typeface="Yu Gothic"/>
                         </a:defRPr>
                       </a:pPr>
                       <a:r>
+                        <a:rPr lang="ja-JP" altLang="en-US"/>
                         <a:t>測定環境・制限</a:t>
                       </a:r>
                     </a:p>
@@ -7342,6 +7482,11 @@
                     </a:solidFill>
                   </a:tcPr>
                 </a:tc>
+                <a:extLst>
+                  <a:ext uri="{0D108BD9-81ED-4DB2-BD59-A6C34878D82A}">
+                    <a16:rowId xmlns:a16="http://schemas.microsoft.com/office/drawing/2014/main" val="10003"/>
+                  </a:ext>
+                </a:extLst>
               </a:tr>
             </a:tbl>
           </a:graphicData>
@@ -7355,8 +7500,8 @@
         </p:nvSpPr>
         <p:spPr>
           <a:xfrm>
-            <a:off x="786384" y="5678424"/>
-            <a:ext cx="10332720" cy="411480"/>
+            <a:off x="566928" y="6172200"/>
+            <a:ext cx="11045952" cy="184666"/>
           </a:xfrm>
           <a:prstGeom prst="rect">
             <a:avLst/>
@@ -7364,7 +7509,7 @@
           <a:noFill/>
         </p:spPr>
         <p:txBody>
-          <a:bodyPr wrap="square" lIns="0" rIns="0" tIns="0" bIns="0">
+          <a:bodyPr wrap="square" lIns="0" tIns="0" rIns="0" bIns="0">
             <a:spAutoFit/>
           </a:bodyPr>
           <a:lstStyle/>
@@ -7375,7 +7520,7 @@
               </a:spcAft>
               <a:defRPr sz="1200" b="0">
                 <a:solidFill>
-                  <a:srgbClr val="696969"/>
+                  <a:srgbClr val="5B6B8A"/>
                 </a:solidFill>
                 <a:latin typeface="Yu Gothic"/>
               </a:defRPr>
@@ -7383,6 +7528,7 @@
             <a:r>
               <a:t>出典・比較条件・単位（実際に使用した値について必須）</a:t>
             </a:r>
+            <a:endParaRPr lang="ja-JP" altLang="en-US"/>
           </a:p>
         </p:txBody>
       </p:sp>
@@ -7394,8 +7540,8 @@
 </p:sld>
 </file>
 
-<file path=ppt/slides/slide7.xml><?xml version="1.0" encoding="utf-8"?>
-<p:sld xmlns:a="http://schemas.openxmlformats.org/drawingml/2006/main" xmlns:p="http://schemas.openxmlformats.org/presentationml/2006/main" xmlns:r="http://schemas.openxmlformats.org/officeDocument/2006/relationships">
+<file path=ppt/slides/slide8.xml><?xml version="1.0" encoding="utf-8"?>
+<p:sld xmlns:a="http://schemas.openxmlformats.org/drawingml/2006/main" xmlns:r="http://schemas.openxmlformats.org/officeDocument/2006/relationships" xmlns:p="http://schemas.openxmlformats.org/presentationml/2006/main">
   <p:cSld>
     <p:bg>
       <p:bgPr>
@@ -7411,7 +7557,14 @@
         <p:cNvGrpSpPr/>
         <p:nvPr/>
       </p:nvGrpSpPr>
-      <p:grpSpPr/>
+      <p:grpSpPr>
+        <a:xfrm>
+          <a:off x="0" y="0"/>
+          <a:ext cx="0" cy="0"/>
+          <a:chOff x="0" y="0"/>
+          <a:chExt cx="0" cy="0"/>
+        </a:xfrm>
+      </p:grpSpPr>
       <p:sp>
         <p:nvSpPr>
           <p:cNvPr id="2" name="TextBox 1"/>
@@ -7421,7 +7574,7 @@
         <p:spPr>
           <a:xfrm>
             <a:off x="566928" y="329184"/>
-            <a:ext cx="10927080" cy="594360"/>
+            <a:ext cx="10927080" cy="461665"/>
           </a:xfrm>
           <a:prstGeom prst="rect">
             <a:avLst/>
@@ -7429,7 +7582,7 @@
           <a:noFill/>
         </p:spPr>
         <p:txBody>
-          <a:bodyPr wrap="square" lIns="0" rIns="0" tIns="0" bIns="0">
+          <a:bodyPr wrap="square" lIns="0" tIns="0" rIns="0" bIns="0">
             <a:spAutoFit/>
           </a:bodyPr>
           <a:lstStyle/>
@@ -7440,7 +7593,7 @@
               </a:spcAft>
               <a:defRPr sz="3000" b="1">
                 <a:solidFill>
-                  <a:srgbClr val="C00000"/>
+                  <a:srgbClr val="0050E6"/>
                 </a:solidFill>
                 <a:latin typeface="Yu Gothic"/>
               </a:defRPr>
@@ -7448,6 +7601,7 @@
             <a:r>
               <a:t>根拠画像の比較：AとB</a:t>
             </a:r>
+            <a:endParaRPr lang="ja-JP" altLang="en-US"/>
           </a:p>
         </p:txBody>
       </p:sp>
@@ -7466,7 +7620,7 @@
             <a:avLst/>
           </a:prstGeom>
           <a:solidFill>
-            <a:srgbClr val="C00000"/>
+            <a:srgbClr val="FFB800"/>
           </a:solidFill>
           <a:ln>
             <a:noFill/>
@@ -7491,45 +7645,7 @@
           <a:lstStyle/>
           <a:p>
             <a:pPr algn="ctr"/>
-          </a:p>
-        </p:txBody>
-      </p:sp>
-      <p:sp>
-        <p:nvSpPr>
-          <p:cNvPr id="4" name="TextBox 3"/>
-          <p:cNvSpPr txBox="1"/>
-          <p:nvPr/>
-        </p:nvSpPr>
-        <p:spPr>
-          <a:xfrm>
-            <a:off x="566928" y="6492240"/>
-            <a:ext cx="10789920" cy="201168"/>
-          </a:xfrm>
-          <a:prstGeom prst="rect">
-            <a:avLst/>
-          </a:prstGeom>
-          <a:noFill/>
-        </p:spPr>
-        <p:txBody>
-          <a:bodyPr wrap="square" lIns="0" rIns="0" tIns="0" bIns="0">
-            <a:spAutoFit/>
-          </a:bodyPr>
-          <a:lstStyle/>
-          <a:p>
-            <a:pPr>
-              <a:spcAft>
-                <a:spcPts val="700"/>
-              </a:spcAft>
-              <a:defRPr sz="900" b="0">
-                <a:solidFill>
-                  <a:srgbClr val="696969"/>
-                </a:solidFill>
-                <a:latin typeface="Yu Gothic"/>
-              </a:defRPr>
-            </a:pPr>
-            <a:r>
-              <a:t>Weekly IT News！  •  レイアウト見本（実際の内容に差し替え）</a:t>
-            </a:r>
+            <a:endParaRPr/>
           </a:p>
         </p:txBody>
       </p:sp>
@@ -7541,14 +7657,14 @@
         </p:nvSpPr>
         <p:spPr>
           <a:xfrm>
-            <a:off x="685800" y="1325880"/>
-            <a:ext cx="5276088" cy="4069080"/>
+            <a:off x="566928" y="1280160"/>
+            <a:ext cx="5394960" cy="4297680"/>
           </a:xfrm>
           <a:prstGeom prst="rect">
             <a:avLst/>
           </a:prstGeom>
           <a:solidFill>
-            <a:srgbClr val="F1F2F4"/>
+            <a:srgbClr val="EAF2FF"/>
           </a:solidFill>
           <a:ln>
             <a:noFill/>
@@ -7573,6 +7689,7 @@
           <a:lstStyle/>
           <a:p>
             <a:pPr algn="ctr"/>
+            <a:endParaRPr/>
           </a:p>
         </p:txBody>
       </p:sp>
@@ -7584,14 +7701,14 @@
         </p:nvSpPr>
         <p:spPr>
           <a:xfrm>
-            <a:off x="6217920" y="1325880"/>
-            <a:ext cx="5276088" cy="4069080"/>
+            <a:off x="6217920" y="1280160"/>
+            <a:ext cx="5394960" cy="4297680"/>
           </a:xfrm>
           <a:prstGeom prst="rect">
             <a:avLst/>
           </a:prstGeom>
           <a:solidFill>
-            <a:srgbClr val="F1F2F4"/>
+            <a:srgbClr val="EAF2FF"/>
           </a:solidFill>
           <a:ln>
             <a:noFill/>
@@ -7616,6 +7733,7 @@
           <a:lstStyle/>
           <a:p>
             <a:pPr algn="ctr"/>
+            <a:endParaRPr/>
           </a:p>
         </p:txBody>
       </p:sp>
@@ -7627,8 +7745,8 @@
         </p:nvSpPr>
         <p:spPr>
           <a:xfrm>
-            <a:off x="1463040" y="3035808"/>
-            <a:ext cx="3657600" cy="457200"/>
+            <a:off x="1435608" y="3246120"/>
+            <a:ext cx="3657600" cy="353943"/>
           </a:xfrm>
           <a:prstGeom prst="rect">
             <a:avLst/>
@@ -7636,7 +7754,7 @@
           <a:noFill/>
         </p:spPr>
         <p:txBody>
-          <a:bodyPr wrap="square" lIns="0" rIns="0" tIns="0" bIns="0">
+          <a:bodyPr wrap="square" lIns="0" tIns="0" rIns="0" bIns="0">
             <a:spAutoFit/>
           </a:bodyPr>
           <a:lstStyle/>
@@ -7647,7 +7765,7 @@
               </a:spcAft>
               <a:defRPr sz="2300" b="0">
                 <a:solidFill>
-                  <a:srgbClr val="696969"/>
+                  <a:srgbClr val="5B6B8A"/>
                 </a:solidFill>
                 <a:latin typeface="Yu Gothic"/>
               </a:defRPr>
@@ -7655,6 +7773,7 @@
             <a:r>
               <a:t>実際の画像 A</a:t>
             </a:r>
+            <a:endParaRPr lang="ja-JP" altLang="en-US"/>
           </a:p>
         </p:txBody>
       </p:sp>
@@ -7666,8 +7785,8 @@
         </p:nvSpPr>
         <p:spPr>
           <a:xfrm>
-            <a:off x="6949440" y="3035808"/>
-            <a:ext cx="3657600" cy="457200"/>
+            <a:off x="7086600" y="3246120"/>
+            <a:ext cx="3657600" cy="353943"/>
           </a:xfrm>
           <a:prstGeom prst="rect">
             <a:avLst/>
@@ -7675,7 +7794,7 @@
           <a:noFill/>
         </p:spPr>
         <p:txBody>
-          <a:bodyPr wrap="square" lIns="0" rIns="0" tIns="0" bIns="0">
+          <a:bodyPr wrap="square" lIns="0" tIns="0" rIns="0" bIns="0">
             <a:spAutoFit/>
           </a:bodyPr>
           <a:lstStyle/>
@@ -7686,7 +7805,7 @@
               </a:spcAft>
               <a:defRPr sz="2300" b="0">
                 <a:solidFill>
-                  <a:srgbClr val="696969"/>
+                  <a:srgbClr val="5B6B8A"/>
                 </a:solidFill>
                 <a:latin typeface="Yu Gothic"/>
               </a:defRPr>
@@ -7694,6 +7813,7 @@
             <a:r>
               <a:t>実際の画像 B</a:t>
             </a:r>
+            <a:endParaRPr lang="ja-JP" altLang="en-US"/>
           </a:p>
         </p:txBody>
       </p:sp>
@@ -7705,8 +7825,8 @@
         </p:nvSpPr>
         <p:spPr>
           <a:xfrm>
-            <a:off x="731520" y="5504688"/>
-            <a:ext cx="5166360" cy="621792"/>
+            <a:off x="566928" y="5760720"/>
+            <a:ext cx="5394960" cy="230832"/>
           </a:xfrm>
           <a:prstGeom prst="rect">
             <a:avLst/>
@@ -7714,7 +7834,7 @@
           <a:noFill/>
         </p:spPr>
         <p:txBody>
-          <a:bodyPr wrap="square" lIns="0" rIns="0" tIns="0" bIns="0">
+          <a:bodyPr wrap="square" lIns="0" tIns="0" rIns="0" bIns="0">
             <a:spAutoFit/>
           </a:bodyPr>
           <a:lstStyle/>
@@ -7725,7 +7845,7 @@
               </a:spcAft>
               <a:defRPr sz="1500" b="0">
                 <a:solidFill>
-                  <a:srgbClr val="1C1C1C"/>
+                  <a:srgbClr val="0A1A3A"/>
                 </a:solidFill>
                 <a:latin typeface="Yu Gothic"/>
               </a:defRPr>
@@ -7733,6 +7853,7 @@
             <a:r>
               <a:t>Aの説明と出典URL</a:t>
             </a:r>
+            <a:endParaRPr lang="ja-JP" altLang="en-US"/>
           </a:p>
         </p:txBody>
       </p:sp>
@@ -7744,8 +7865,8 @@
         </p:nvSpPr>
         <p:spPr>
           <a:xfrm>
-            <a:off x="6291072" y="5504688"/>
-            <a:ext cx="5166360" cy="621792"/>
+            <a:off x="6217920" y="5760720"/>
+            <a:ext cx="5394960" cy="230832"/>
           </a:xfrm>
           <a:prstGeom prst="rect">
             <a:avLst/>
@@ -7753,7 +7874,7 @@
           <a:noFill/>
         </p:spPr>
         <p:txBody>
-          <a:bodyPr wrap="square" lIns="0" rIns="0" tIns="0" bIns="0">
+          <a:bodyPr wrap="square" lIns="0" tIns="0" rIns="0" bIns="0">
             <a:spAutoFit/>
           </a:bodyPr>
           <a:lstStyle/>
@@ -7764,7 +7885,7 @@
               </a:spcAft>
               <a:defRPr sz="1500" b="0">
                 <a:solidFill>
-                  <a:srgbClr val="1C1C1C"/>
+                  <a:srgbClr val="0A1A3A"/>
                 </a:solidFill>
                 <a:latin typeface="Yu Gothic"/>
               </a:defRPr>
@@ -7772,6 +7893,7 @@
             <a:r>
               <a:t>Bの説明と出典URL</a:t>
             </a:r>
+            <a:endParaRPr lang="ja-JP" altLang="en-US"/>
           </a:p>
         </p:txBody>
       </p:sp>
@@ -8280,21 +8402,6 @@
 </file>
 
 <file path=customXml/item1.xml><?xml version="1.0" encoding="utf-8"?>
-<?mso-contentType ?>
-<FormTemplates xmlns="http://schemas.microsoft.com/sharepoint/v3/contenttype/forms">
-  <Display>DocumentLibraryForm</Display>
-  <Edit>DocumentLibraryForm</Edit>
-  <New>DocumentLibraryForm</New>
-</FormTemplates>
-</file>
-
-<file path=customXml/item2.xml><?xml version="1.0" encoding="utf-8"?>
-<p:properties xmlns:p="http://schemas.microsoft.com/office/2006/metadata/properties" xmlns:xsi="http://www.w3.org/2001/XMLSchema-instance" xmlns:pc="http://schemas.microsoft.com/office/infopath/2007/PartnerControls">
-  <documentManagement/>
-</p:properties>
-</file>
-
-<file path=customXml/item3.xml><?xml version="1.0" encoding="utf-8"?>
 <ct:contentTypeSchema xmlns:ct="http://schemas.microsoft.com/office/2006/metadata/contentType" xmlns:ma="http://schemas.microsoft.com/office/2006/metadata/properties/metaAttributes" ct:_="" ma:_="" ma:contentTypeName="Document" ma:contentTypeID="0x0101002A33C2428CF3C748A168279D7D5F572F" ma:contentTypeVersion="13" ma:contentTypeDescription="Create a new document." ma:contentTypeScope="" ma:versionID="820de0148b10ca8ddbdada93a8acfb75">
   <xsd:schema xmlns:xsd="http://www.w3.org/2001/XMLSchema" xmlns:xs="http://www.w3.org/2001/XMLSchema" xmlns:p="http://schemas.microsoft.com/office/2006/metadata/properties" xmlns:ns3="22198d8e-ba44-4c0a-adf9-6df7e80845ef" xmlns:ns4="bb1247fa-8ce5-4493-9b66-cc3bdd173246" targetNamespace="http://schemas.microsoft.com/office/2006/metadata/properties" ma:root="true" ma:fieldsID="4f052d76f861d92b69cd61c836ab31bf" ns3:_="" ns4:_="">
     <xsd:import namespace="22198d8e-ba44-4c0a-adf9-6df7e80845ef"/>
@@ -8517,10 +8624,36 @@
 </ct:contentTypeSchema>
 </file>
 
+<file path=customXml/item2.xml><?xml version="1.0" encoding="utf-8"?>
+<p:properties xmlns:p="http://schemas.microsoft.com/office/2006/metadata/properties" xmlns:xsi="http://www.w3.org/2001/XMLSchema-instance" xmlns:pc="http://schemas.microsoft.com/office/infopath/2007/PartnerControls">
+  <documentManagement/>
+</p:properties>
+</file>
+
+<file path=customXml/item3.xml><?xml version="1.0" encoding="utf-8"?>
+<?mso-contentType ?>
+<FormTemplates xmlns="http://schemas.microsoft.com/sharepoint/v3/contenttype/forms">
+  <Display>DocumentLibraryForm</Display>
+  <Edit>DocumentLibraryForm</Edit>
+  <New>DocumentLibraryForm</New>
+</FormTemplates>
+</file>
+
 <file path=customXml/itemProps1.xml><?xml version="1.0" encoding="utf-8"?>
-<ds:datastoreItem xmlns:ds="http://schemas.openxmlformats.org/officeDocument/2006/customXml" ds:itemID="{4E2BF19F-A865-4DE7-9551-D93A24C9134C}">
+<ds:datastoreItem xmlns:ds="http://schemas.openxmlformats.org/officeDocument/2006/customXml" ds:itemID="{442DCCA7-9FF0-40F0-B0DC-79EA5E5E3630}">
   <ds:schemaRefs>
-    <ds:schemaRef ds:uri="http://schemas.microsoft.com/sharepoint/v3/contenttype/forms"/>
+    <ds:schemaRef ds:uri="22198d8e-ba44-4c0a-adf9-6df7e80845ef"/>
+    <ds:schemaRef ds:uri="bb1247fa-8ce5-4493-9b66-cc3bdd173246"/>
+    <ds:schemaRef ds:uri="http://purl.org/dc/elements/1.1/"/>
+    <ds:schemaRef ds:uri="http://purl.org/dc/terms/"/>
+    <ds:schemaRef ds:uri="http://schemas.microsoft.com/internal/obd"/>
+    <ds:schemaRef ds:uri="http://schemas.microsoft.com/office/2006/documentManagement/types"/>
+    <ds:schemaRef ds:uri="http://schemas.microsoft.com/office/2006/metadata/contentType"/>
+    <ds:schemaRef ds:uri="http://schemas.microsoft.com/office/2006/metadata/properties"/>
+    <ds:schemaRef ds:uri="http://schemas.microsoft.com/office/2006/metadata/properties/metaAttributes"/>
+    <ds:schemaRef ds:uri="http://schemas.microsoft.com/office/infopath/2007/PartnerControls"/>
+    <ds:schemaRef ds:uri="http://schemas.openxmlformats.org/package/2006/metadata/core-properties"/>
+    <ds:schemaRef ds:uri="http://www.w3.org/2001/XMLSchema"/>
   </ds:schemaRefs>
 </ds:datastoreItem>
 </file>
@@ -8543,20 +8676,9 @@
 </file>
 
 <file path=customXml/itemProps3.xml><?xml version="1.0" encoding="utf-8"?>
-<ds:datastoreItem xmlns:ds="http://schemas.openxmlformats.org/officeDocument/2006/customXml" ds:itemID="{442DCCA7-9FF0-40F0-B0DC-79EA5E5E3630}">
+<ds:datastoreItem xmlns:ds="http://schemas.openxmlformats.org/officeDocument/2006/customXml" ds:itemID="{4E2BF19F-A865-4DE7-9551-D93A24C9134C}">
   <ds:schemaRefs>
-    <ds:schemaRef ds:uri="22198d8e-ba44-4c0a-adf9-6df7e80845ef"/>
-    <ds:schemaRef ds:uri="bb1247fa-8ce5-4493-9b66-cc3bdd173246"/>
-    <ds:schemaRef ds:uri="http://purl.org/dc/elements/1.1/"/>
-    <ds:schemaRef ds:uri="http://purl.org/dc/terms/"/>
-    <ds:schemaRef ds:uri="http://schemas.microsoft.com/internal/obd"/>
-    <ds:schemaRef ds:uri="http://schemas.microsoft.com/office/2006/documentManagement/types"/>
-    <ds:schemaRef ds:uri="http://schemas.microsoft.com/office/2006/metadata/contentType"/>
-    <ds:schemaRef ds:uri="http://schemas.microsoft.com/office/2006/metadata/properties"/>
-    <ds:schemaRef ds:uri="http://schemas.microsoft.com/office/2006/metadata/properties/metaAttributes"/>
-    <ds:schemaRef ds:uri="http://schemas.microsoft.com/office/infopath/2007/PartnerControls"/>
-    <ds:schemaRef ds:uri="http://schemas.openxmlformats.org/package/2006/metadata/core-properties"/>
-    <ds:schemaRef ds:uri="http://www.w3.org/2001/XMLSchema"/>
+    <ds:schemaRef ds:uri="http://schemas.microsoft.com/sharepoint/v3/contenttype/forms"/>
   </ds:schemaRefs>
 </ds:datastoreItem>
 </file>
</xml_diff>